<commit_message>
remove some test files
</commit_message>
<xml_diff>
--- a/20260514_docx_to_markdown/final/fixtures/pptx/sample.pptx
+++ b/20260514_docx_to_markdown/final/fixtures/pptx/sample.pptx
@@ -4,16 +4,18 @@
   <p:sldMasterIdLst>
     <p:sldMasterId id="2147483648" r:id="rId1"/>
   </p:sldMasterIdLst>
+  <p:notesMasterIdLst>
+    <p:notesMasterId r:id="rId8"/>
+  </p:notesMasterIdLst>
   <p:sldIdLst>
     <p:sldId id="256" r:id="rId2"/>
     <p:sldId id="257" r:id="rId3"/>
     <p:sldId id="258" r:id="rId4"/>
     <p:sldId id="259" r:id="rId5"/>
+    <p:sldId id="260" r:id="rId6"/>
+    <p:sldId id="261" r:id="rId7"/>
   </p:sldIdLst>
-  <p:notesMasterIdLst>
-    <p:notesMasterId r:id="rId6"/>
-  </p:notesMasterIdLst>
-  <p:sldSz cx="9144000" cy="5143500"/>
+  <p:sldSz cx="9144000" cy="5143500" type="screen16x9"/>
   <p:notesSz cx="5143500" cy="9144000"/>
   <p:defaultTextStyle>
     <a:lvl1pPr marL="0" algn="l" defTabSz="914400" rtl="0" eaLnBrk="1" latinLnBrk="0" hangingPunct="1">
@@ -107,6 +109,11 @@
       </a:defRPr>
     </a:lvl9pPr>
   </p:defaultTextStyle>
+  <p:extLst>
+    <p:ext uri="{EFAFB233-063F-42B5-8137-9DF3F51BA10A}">
+      <p15:sldGuideLst xmlns:p15="http://schemas.microsoft.com/office/powerpoint/2012/main"/>
+    </p:ext>
+  </p:extLst>
 </p:presentation>
 </file>
 
@@ -132,241 +139,17 @@
           <a:chExt cx="0" cy="0"/>
         </a:xfrm>
       </p:grpSpPr>
-      <p:sp>
-        <p:nvSpPr>
-          <p:cNvPr id="2" name="Header Placeholder 1"/>
-          <p:cNvSpPr>
-            <a:spLocks noGrp="1"/>
-          </p:cNvSpPr>
-          <p:nvPr>
-            <p:ph type="hdr" sz="quarter"/>
-          </p:nvPr>
-        </p:nvSpPr>
-        <p:spPr>
-          <a:xfrm>
-            <a:off x="0" y="0"/>
-            <a:ext cx="2971800" cy="458788"/>
-          </a:xfrm>
-          <a:prstGeom prst="rect">
-            <a:avLst/>
-          </a:prstGeom>
-        </p:spPr>
-        <p:txBody>
-          <a:bodyPr vert="horz" lIns="91440" tIns="45720" rIns="91440" bIns="45720" rtlCol="0"/>
-          <a:lstStyle>
-            <a:lvl1pPr algn="l">
-              <a:defRPr sz="1200"/>
-            </a:lvl1pPr>
-          </a:lstStyle>
-          <a:p>
-            <a:endParaRPr lang="en-US"/>
-          </a:p>
-        </p:txBody>
-      </p:sp>
-      <p:sp>
-        <p:nvSpPr>
-          <p:cNvPr id="3" name="Date Placeholder 2"/>
-          <p:cNvSpPr>
-            <a:spLocks noGrp="1"/>
-          </p:cNvSpPr>
-          <p:nvPr>
-            <p:ph type="dt" idx="1"/>
-          </p:nvPr>
-        </p:nvSpPr>
-        <p:spPr>
-          <a:xfrm>
-            <a:off x="3884613" y="0"/>
-            <a:ext cx="2971800" cy="458788"/>
-          </a:xfrm>
-          <a:prstGeom prst="rect">
-            <a:avLst/>
-          </a:prstGeom>
-        </p:spPr>
-        <p:txBody>
-          <a:bodyPr vert="horz" lIns="91440" tIns="45720" rIns="91440" bIns="45720" rtlCol="0"/>
-          <a:lstStyle>
-            <a:lvl1pPr algn="r">
-              <a:defRPr sz="1200"/>
-            </a:lvl1pPr>
-          </a:lstStyle>
-          <a:p>
-            <a:fld id="{5282F153-3F37-0F45-9E97-73ACFA13230C}" type="datetimeFigureOut">
-              <a:rPr lang="en-US"/>
-              <a:t>7/23/19</a:t>
-            </a:fld>
-            <a:endParaRPr lang="en-US"/>
-          </a:p>
-        </p:txBody>
-      </p:sp>
-      <p:sp>
-        <p:nvSpPr>
-          <p:cNvPr id="4" name="Slide Image Placeholder 3"/>
-          <p:cNvSpPr>
-            <a:spLocks noGrp="1" noRot="1" noChangeAspect="1"/>
-          </p:cNvSpPr>
-          <p:nvPr>
-            <p:ph type="sldImg" idx="2"/>
-          </p:nvPr>
-        </p:nvSpPr>
-        <p:spPr>
-          <a:xfrm>
-            <a:off x="685800" y="1143000"/>
-            <a:ext cx="5486400" cy="3086100"/>
-          </a:xfrm>
-          <a:prstGeom prst="rect">
-            <a:avLst/>
-          </a:prstGeom>
-          <a:noFill/>
-          <a:ln w="12700">
-            <a:solidFill>
-              <a:prstClr val="black"/>
-            </a:solidFill>
-          </a:ln>
-        </p:spPr>
-        <p:txBody>
-          <a:bodyPr vert="horz" lIns="91440" tIns="45720" rIns="91440" bIns="45720" rtlCol="0" anchor="ctr"/>
-          <a:lstStyle/>
-          <a:p>
-            <a:endParaRPr lang="en-US"/>
-          </a:p>
-        </p:txBody>
-      </p:sp>
-      <p:sp>
-        <p:nvSpPr>
-          <p:cNvPr id="5" name="Notes Placeholder 4"/>
-          <p:cNvSpPr>
-            <a:spLocks noGrp="1"/>
-          </p:cNvSpPr>
-          <p:nvPr>
-            <p:ph type="body" sz="quarter" idx="3"/>
-          </p:nvPr>
-        </p:nvSpPr>
-        <p:spPr>
-          <a:xfrm>
-            <a:off x="685800" y="4400550"/>
-            <a:ext cx="5486400" cy="3600450"/>
-          </a:xfrm>
-          <a:prstGeom prst="rect">
-            <a:avLst/>
-          </a:prstGeom>
-        </p:spPr>
-        <p:txBody>
-          <a:bodyPr vert="horz" lIns="91440" tIns="45720" rIns="91440" bIns="45720" rtlCol="0"/>
-          <a:lstStyle/>
-          <a:p>
-            <a:pPr lvl="0"/>
-            <a:r>
-              <a:rPr lang="en-US"/>
-              <a:t>Click to edit Master text styles</a:t>
-            </a:r>
-          </a:p>
-          <a:p>
-            <a:pPr lvl="1"/>
-            <a:r>
-              <a:rPr lang="en-US"/>
-              <a:t>Second level</a:t>
-            </a:r>
-          </a:p>
-          <a:p>
-            <a:pPr lvl="2"/>
-            <a:r>
-              <a:rPr lang="en-US"/>
-              <a:t>Third level</a:t>
-            </a:r>
-          </a:p>
-          <a:p>
-            <a:pPr lvl="3"/>
-            <a:r>
-              <a:rPr lang="en-US"/>
-              <a:t>Fourth level</a:t>
-            </a:r>
-          </a:p>
-          <a:p>
-            <a:pPr lvl="4"/>
-            <a:r>
-              <a:rPr lang="en-US"/>
-              <a:t>Fifth level</a:t>
-            </a:r>
-          </a:p>
-        </p:txBody>
-      </p:sp>
-      <p:sp>
-        <p:nvSpPr>
-          <p:cNvPr id="6" name="Footer Placeholder 5"/>
-          <p:cNvSpPr>
-            <a:spLocks noGrp="1"/>
-          </p:cNvSpPr>
-          <p:nvPr>
-            <p:ph type="ftr" sz="quarter" idx="4"/>
-          </p:nvPr>
-        </p:nvSpPr>
-        <p:spPr>
-          <a:xfrm>
-            <a:off x="0" y="8685213"/>
-            <a:ext cx="2971800" cy="458787"/>
-          </a:xfrm>
-          <a:prstGeom prst="rect">
-            <a:avLst/>
-          </a:prstGeom>
-        </p:spPr>
-        <p:txBody>
-          <a:bodyPr vert="horz" lIns="91440" tIns="45720" rIns="91440" bIns="45720" rtlCol="0" anchor="b"/>
-          <a:lstStyle>
-            <a:lvl1pPr algn="l">
-              <a:defRPr sz="1200"/>
-            </a:lvl1pPr>
-          </a:lstStyle>
-          <a:p>
-            <a:endParaRPr lang="en-US"/>
-          </a:p>
-        </p:txBody>
-      </p:sp>
-      <p:sp>
-        <p:nvSpPr>
-          <p:cNvPr id="7" name="Slide Number Placeholder 6"/>
-          <p:cNvSpPr>
-            <a:spLocks noGrp="1"/>
-          </p:cNvSpPr>
-          <p:nvPr>
-            <p:ph type="sldNum" sz="quarter" idx="5"/>
-          </p:nvPr>
-        </p:nvSpPr>
-        <p:spPr>
-          <a:xfrm>
-            <a:off x="3884613" y="8685213"/>
-            <a:ext cx="2971800" cy="458787"/>
-          </a:xfrm>
-          <a:prstGeom prst="rect">
-            <a:avLst/>
-          </a:prstGeom>
-        </p:spPr>
-        <p:txBody>
-          <a:bodyPr vert="horz" lIns="91440" tIns="45720" rIns="91440" bIns="45720" rtlCol="0" anchor="b"/>
-          <a:lstStyle>
-            <a:lvl1pPr algn="r">
-              <a:defRPr sz="1200"/>
-            </a:lvl1pPr>
-          </a:lstStyle>
-          <a:p>
-            <a:fld id="{CE5E9CC1-C706-0F49-92D6-E571CC5EEA8F}" type="slidenum">
-              <a:rPr lang="en-US"/>
-              <a:t>‹#›</a:t>
-            </a:fld>
-            <a:endParaRPr lang="en-US"/>
-          </a:p>
-        </p:txBody>
-      </p:sp>
     </p:spTree>
     <p:extLst>
       <p:ext uri="{BB962C8B-B14F-4D97-AF65-F5344CB8AC3E}">
-        <p14:creationId xmlns:p14="http://schemas.microsoft.com/office/powerpoint/2010/main" val="1024086991"/>
+        <p14:creationId xmlns:p14="http://schemas.microsoft.com/office/powerpoint/2010/main" val="1450700345"/>
       </p:ext>
     </p:extLst>
   </p:cSld>
   <p:clrMap bg1="lt1" tx1="dk1" bg2="lt2" tx2="dk2" accent1="accent1" accent2="accent2" accent3="accent3" accent4="accent4" accent5="accent5" accent6="accent6" hlink="hlink" folHlink="folHlink"/>
   <p:notesStyle>
     <a:lvl1pPr marL="0" algn="l" defTabSz="914400" rtl="0" eaLnBrk="1" latinLnBrk="0" hangingPunct="1">
-      <a:defRPr sz="1200" kern="1200">
+      <a:defRPr kumimoji="1" sz="1200" kern="1200">
         <a:solidFill>
           <a:schemeClr val="tx1"/>
         </a:solidFill>
@@ -376,7 +159,7 @@
       </a:defRPr>
     </a:lvl1pPr>
     <a:lvl2pPr marL="457200" algn="l" defTabSz="914400" rtl="0" eaLnBrk="1" latinLnBrk="0" hangingPunct="1">
-      <a:defRPr sz="1200" kern="1200">
+      <a:defRPr kumimoji="1" sz="1200" kern="1200">
         <a:solidFill>
           <a:schemeClr val="tx1"/>
         </a:solidFill>
@@ -386,7 +169,7 @@
       </a:defRPr>
     </a:lvl2pPr>
     <a:lvl3pPr marL="914400" algn="l" defTabSz="914400" rtl="0" eaLnBrk="1" latinLnBrk="0" hangingPunct="1">
-      <a:defRPr sz="1200" kern="1200">
+      <a:defRPr kumimoji="1" sz="1200" kern="1200">
         <a:solidFill>
           <a:schemeClr val="tx1"/>
         </a:solidFill>
@@ -396,7 +179,7 @@
       </a:defRPr>
     </a:lvl3pPr>
     <a:lvl4pPr marL="1371600" algn="l" defTabSz="914400" rtl="0" eaLnBrk="1" latinLnBrk="0" hangingPunct="1">
-      <a:defRPr sz="1200" kern="1200">
+      <a:defRPr kumimoji="1" sz="1200" kern="1200">
         <a:solidFill>
           <a:schemeClr val="tx1"/>
         </a:solidFill>
@@ -406,7 +189,7 @@
       </a:defRPr>
     </a:lvl4pPr>
     <a:lvl5pPr marL="1828800" algn="l" defTabSz="914400" rtl="0" eaLnBrk="1" latinLnBrk="0" hangingPunct="1">
-      <a:defRPr sz="1200" kern="1200">
+      <a:defRPr kumimoji="1" sz="1200" kern="1200">
         <a:solidFill>
           <a:schemeClr val="tx1"/>
         </a:solidFill>
@@ -416,7 +199,7 @@
       </a:defRPr>
     </a:lvl5pPr>
     <a:lvl6pPr marL="2286000" algn="l" defTabSz="914400" rtl="0" eaLnBrk="1" latinLnBrk="0" hangingPunct="1">
-      <a:defRPr sz="1200" kern="1200">
+      <a:defRPr kumimoji="1" sz="1200" kern="1200">
         <a:solidFill>
           <a:schemeClr val="tx1"/>
         </a:solidFill>
@@ -426,7 +209,7 @@
       </a:defRPr>
     </a:lvl6pPr>
     <a:lvl7pPr marL="2743200" algn="l" defTabSz="914400" rtl="0" eaLnBrk="1" latinLnBrk="0" hangingPunct="1">
-      <a:defRPr sz="1200" kern="1200">
+      <a:defRPr kumimoji="1" sz="1200" kern="1200">
         <a:solidFill>
           <a:schemeClr val="tx1"/>
         </a:solidFill>
@@ -436,7 +219,7 @@
       </a:defRPr>
     </a:lvl7pPr>
     <a:lvl8pPr marL="3200400" algn="l" defTabSz="914400" rtl="0" eaLnBrk="1" latinLnBrk="0" hangingPunct="1">
-      <a:defRPr sz="1200" kern="1200">
+      <a:defRPr kumimoji="1" sz="1200" kern="1200">
         <a:solidFill>
           <a:schemeClr val="tx1"/>
         </a:solidFill>
@@ -446,7 +229,7 @@
       </a:defRPr>
     </a:lvl8pPr>
     <a:lvl9pPr marL="3657600" algn="l" defTabSz="914400" rtl="0" eaLnBrk="1" latinLnBrk="0" hangingPunct="1">
-      <a:defRPr sz="1200" kern="1200">
+      <a:defRPr kumimoji="1" sz="1200" kern="1200">
         <a:solidFill>
           <a:schemeClr val="tx1"/>
         </a:solidFill>
@@ -503,10 +286,6 @@
           <a:bodyPr/>
           <a:lstStyle/>
           <a:p>
-            <a:r>
-              <a:rPr lang="en-US" dirty="0"/>
-              <a:t/>
-            </a:r>
             <a:endParaRPr lang="en-US" dirty="0"/>
           </a:p>
         </p:txBody>
@@ -591,10 +370,6 @@
           <a:bodyPr/>
           <a:lstStyle/>
           <a:p>
-            <a:r>
-              <a:rPr lang="en-US" dirty="0"/>
-              <a:t/>
-            </a:r>
             <a:endParaRPr lang="en-US" dirty="0"/>
           </a:p>
         </p:txBody>
@@ -679,10 +454,6 @@
           <a:bodyPr/>
           <a:lstStyle/>
           <a:p>
-            <a:r>
-              <a:rPr lang="en-US" dirty="0"/>
-              <a:t/>
-            </a:r>
             <a:endParaRPr lang="en-US" dirty="0"/>
           </a:p>
         </p:txBody>
@@ -767,10 +538,6 @@
           <a:bodyPr/>
           <a:lstStyle/>
           <a:p>
-            <a:r>
-              <a:rPr lang="en-US" dirty="0"/>
-              <a:t/>
-            </a:r>
             <a:endParaRPr lang="en-US" dirty="0"/>
           </a:p>
         </p:txBody>
@@ -844,6 +611,11 @@
 <file path=ppt/slideMasters/slideMaster1.xml><?xml version="1.0" encoding="utf-8"?>
 <p:sldMaster xmlns:a="http://schemas.openxmlformats.org/drawingml/2006/main" xmlns:r="http://schemas.openxmlformats.org/officeDocument/2006/relationships" xmlns:p="http://schemas.openxmlformats.org/presentationml/2006/main">
   <p:cSld>
+    <p:bg>
+      <p:bgRef idx="1001">
+        <a:schemeClr val="bg1"/>
+      </p:bgRef>
+    </p:bg>
     <p:spTree>
       <p:nvGrpSpPr>
         <p:cNvPr id="1" name=""/>
@@ -1156,7 +928,7 @@
           <a:bodyPr wrap="square" rtlCol="0" anchor="ctr"/>
           <a:lstStyle/>
           <a:p>
-            <a:pPr indent="0" marL="0">
+            <a:pPr marL="0" indent="0">
               <a:buNone/>
             </a:pPr>
             <a:r>
@@ -1192,7 +964,7 @@
           <a:bodyPr wrap="square" rtlCol="0" anchor="ctr"/>
           <a:lstStyle/>
           <a:p>
-            <a:pPr indent="0" marL="0">
+            <a:pPr marL="0" indent="0">
               <a:buNone/>
             </a:pPr>
             <a:r>
@@ -1253,7 +1025,7 @@
           <a:bodyPr wrap="square" rtlCol="0" anchor="ctr"/>
           <a:lstStyle/>
           <a:p>
-            <a:pPr indent="0" marL="0">
+            <a:pPr marL="0" indent="0">
               <a:buNone/>
             </a:pPr>
             <a:r>
@@ -1291,10 +1063,34 @@
             <a:tbl>
               <a:tblPr/>
               <a:tblGrid>
-                <a:gridCol w="2057400"/>
-                <a:gridCol w="2057400"/>
-                <a:gridCol w="2057400"/>
-                <a:gridCol w="2057400"/>
+                <a:gridCol w="2057400">
+                  <a:extLst>
+                    <a:ext uri="{9D8B030D-6E8A-4147-A177-3AD203B41FA5}">
+                      <a16:colId xmlns:a16="http://schemas.microsoft.com/office/drawing/2014/main" val="20000"/>
+                    </a:ext>
+                  </a:extLst>
+                </a:gridCol>
+                <a:gridCol w="2057400">
+                  <a:extLst>
+                    <a:ext uri="{9D8B030D-6E8A-4147-A177-3AD203B41FA5}">
+                      <a16:colId xmlns:a16="http://schemas.microsoft.com/office/drawing/2014/main" val="20001"/>
+                    </a:ext>
+                  </a:extLst>
+                </a:gridCol>
+                <a:gridCol w="2057400">
+                  <a:extLst>
+                    <a:ext uri="{9D8B030D-6E8A-4147-A177-3AD203B41FA5}">
+                      <a16:colId xmlns:a16="http://schemas.microsoft.com/office/drawing/2014/main" val="20002"/>
+                    </a:ext>
+                  </a:extLst>
+                </a:gridCol>
+                <a:gridCol w="2057400">
+                  <a:extLst>
+                    <a:ext uri="{9D8B030D-6E8A-4147-A177-3AD203B41FA5}">
+                      <a16:colId xmlns:a16="http://schemas.microsoft.com/office/drawing/2014/main" val="20003"/>
+                    </a:ext>
+                  </a:extLst>
+                </a:gridCol>
               </a:tblGrid>
               <a:tr h="0">
                 <a:tc>
@@ -1302,7 +1098,7 @@
                     <a:bodyPr/>
                     <a:lstStyle/>
                     <a:p>
-                      <a:pPr indent="0" marL="0">
+                      <a:pPr marL="0" indent="0">
                         <a:buNone/>
                       </a:pPr>
                       <a:r>
@@ -1316,7 +1112,7 @@
                       <a:endParaRPr lang="en-US" sz="1600" dirty="0"/>
                     </a:p>
                   </a:txBody>
-                  <a:tcPr marL="91440" marR="91440" marT="45720" marB="45720">
+                  <a:tcPr>
                     <a:lnL w="0" cap="flat" cmpd="sng" algn="ctr">
                       <a:noFill/>
                     </a:lnL>
@@ -1336,7 +1132,7 @@
                     <a:bodyPr/>
                     <a:lstStyle/>
                     <a:p>
-                      <a:pPr indent="0" marL="0">
+                      <a:pPr marL="0" indent="0">
                         <a:buNone/>
                       </a:pPr>
                       <a:r>
@@ -1350,7 +1146,7 @@
                       <a:endParaRPr lang="en-US" sz="1600" dirty="0"/>
                     </a:p>
                   </a:txBody>
-                  <a:tcPr marL="91440" marR="91440" marT="45720" marB="45720">
+                  <a:tcPr>
                     <a:lnL w="0" cap="flat" cmpd="sng" algn="ctr">
                       <a:noFill/>
                     </a:lnL>
@@ -1370,7 +1166,7 @@
                     <a:bodyPr/>
                     <a:lstStyle/>
                     <a:p>
-                      <a:pPr indent="0" marL="0">
+                      <a:pPr marL="0" indent="0">
                         <a:buNone/>
                       </a:pPr>
                       <a:r>
@@ -1384,7 +1180,7 @@
                       <a:endParaRPr lang="en-US" sz="1600" dirty="0"/>
                     </a:p>
                   </a:txBody>
-                  <a:tcPr marL="91440" marR="91440" marT="45720" marB="45720">
+                  <a:tcPr>
                     <a:lnL w="0" cap="flat" cmpd="sng" algn="ctr">
                       <a:noFill/>
                     </a:lnL>
@@ -1404,7 +1200,7 @@
                     <a:bodyPr/>
                     <a:lstStyle/>
                     <a:p>
-                      <a:pPr indent="0" marL="0">
+                      <a:pPr marL="0" indent="0">
                         <a:buNone/>
                       </a:pPr>
                       <a:r>
@@ -1418,7 +1214,7 @@
                       <a:endParaRPr lang="en-US" sz="1600" dirty="0"/>
                     </a:p>
                   </a:txBody>
-                  <a:tcPr marL="91440" marR="91440" marT="45720" marB="45720">
+                  <a:tcPr>
                     <a:lnL w="0" cap="flat" cmpd="sng" algn="ctr">
                       <a:noFill/>
                     </a:lnL>
@@ -1433,6 +1229,11 @@
                     </a:lnB>
                   </a:tcPr>
                 </a:tc>
+                <a:extLst>
+                  <a:ext uri="{0D108BD9-81ED-4DB2-BD59-A6C34878D82A}">
+                    <a16:rowId xmlns:a16="http://schemas.microsoft.com/office/drawing/2014/main" val="10000"/>
+                  </a:ext>
+                </a:extLst>
               </a:tr>
               <a:tr h="0">
                 <a:tc>
@@ -1440,7 +1241,7 @@
                     <a:bodyPr/>
                     <a:lstStyle/>
                     <a:p>
-                      <a:pPr indent="0" marL="0">
+                      <a:pPr marL="0" indent="0">
                         <a:buNone/>
                       </a:pPr>
                       <a:r>
@@ -1454,7 +1255,7 @@
                       <a:endParaRPr lang="en-US" sz="1600" dirty="0"/>
                     </a:p>
                   </a:txBody>
-                  <a:tcPr marL="91440" marR="91440" marT="45720" marB="45720">
+                  <a:tcPr>
                     <a:lnL w="0" cap="flat" cmpd="sng" algn="ctr">
                       <a:noFill/>
                     </a:lnL>
@@ -1474,7 +1275,7 @@
                     <a:bodyPr/>
                     <a:lstStyle/>
                     <a:p>
-                      <a:pPr indent="0" marL="0">
+                      <a:pPr marL="0" indent="0">
                         <a:buNone/>
                       </a:pPr>
                       <a:r>
@@ -1488,7 +1289,7 @@
                       <a:endParaRPr lang="en-US" sz="1600" dirty="0"/>
                     </a:p>
                   </a:txBody>
-                  <a:tcPr marL="91440" marR="91440" marT="45720" marB="45720">
+                  <a:tcPr>
                     <a:lnL w="0" cap="flat" cmpd="sng" algn="ctr">
                       <a:noFill/>
                     </a:lnL>
@@ -1508,7 +1309,7 @@
                     <a:bodyPr/>
                     <a:lstStyle/>
                     <a:p>
-                      <a:pPr indent="0" marL="0">
+                      <a:pPr marL="0" indent="0">
                         <a:buNone/>
                       </a:pPr>
                       <a:r>
@@ -1522,7 +1323,7 @@
                       <a:endParaRPr lang="en-US" sz="1600" dirty="0"/>
                     </a:p>
                   </a:txBody>
-                  <a:tcPr marL="91440" marR="91440" marT="45720" marB="45720">
+                  <a:tcPr>
                     <a:lnL w="0" cap="flat" cmpd="sng" algn="ctr">
                       <a:noFill/>
                     </a:lnL>
@@ -1542,7 +1343,7 @@
                     <a:bodyPr/>
                     <a:lstStyle/>
                     <a:p>
-                      <a:pPr indent="0" marL="0">
+                      <a:pPr marL="0" indent="0">
                         <a:buNone/>
                       </a:pPr>
                       <a:r>
@@ -1556,7 +1357,7 @@
                       <a:endParaRPr lang="en-US" sz="1600" dirty="0"/>
                     </a:p>
                   </a:txBody>
-                  <a:tcPr marL="91440" marR="91440" marT="45720" marB="45720">
+                  <a:tcPr>
                     <a:lnL w="0" cap="flat" cmpd="sng" algn="ctr">
                       <a:noFill/>
                     </a:lnL>
@@ -1571,6 +1372,11 @@
                     </a:lnB>
                   </a:tcPr>
                 </a:tc>
+                <a:extLst>
+                  <a:ext uri="{0D108BD9-81ED-4DB2-BD59-A6C34878D82A}">
+                    <a16:rowId xmlns:a16="http://schemas.microsoft.com/office/drawing/2014/main" val="10001"/>
+                  </a:ext>
+                </a:extLst>
               </a:tr>
               <a:tr h="0">
                 <a:tc>
@@ -1578,7 +1384,7 @@
                     <a:bodyPr/>
                     <a:lstStyle/>
                     <a:p>
-                      <a:pPr indent="0" marL="0">
+                      <a:pPr marL="0" indent="0">
                         <a:buNone/>
                       </a:pPr>
                       <a:r>
@@ -1592,7 +1398,7 @@
                       <a:endParaRPr lang="en-US" sz="1600" dirty="0"/>
                     </a:p>
                   </a:txBody>
-                  <a:tcPr marL="91440" marR="91440" marT="45720" marB="45720">
+                  <a:tcPr>
                     <a:lnL w="0" cap="flat" cmpd="sng" algn="ctr">
                       <a:noFill/>
                     </a:lnL>
@@ -1612,7 +1418,7 @@
                     <a:bodyPr/>
                     <a:lstStyle/>
                     <a:p>
-                      <a:pPr indent="0" marL="0">
+                      <a:pPr marL="0" indent="0">
                         <a:buNone/>
                       </a:pPr>
                       <a:r>
@@ -1626,7 +1432,7 @@
                       <a:endParaRPr lang="en-US" sz="1600" dirty="0"/>
                     </a:p>
                   </a:txBody>
-                  <a:tcPr marL="91440" marR="91440" marT="45720" marB="45720">
+                  <a:tcPr>
                     <a:lnL w="0" cap="flat" cmpd="sng" algn="ctr">
                       <a:noFill/>
                     </a:lnL>
@@ -1646,7 +1452,7 @@
                     <a:bodyPr/>
                     <a:lstStyle/>
                     <a:p>
-                      <a:pPr indent="0" marL="0">
+                      <a:pPr marL="0" indent="0">
                         <a:buNone/>
                       </a:pPr>
                       <a:r>
@@ -1660,7 +1466,7 @@
                       <a:endParaRPr lang="en-US" sz="1600" dirty="0"/>
                     </a:p>
                   </a:txBody>
-                  <a:tcPr marL="91440" marR="91440" marT="45720" marB="45720">
+                  <a:tcPr>
                     <a:lnL w="0" cap="flat" cmpd="sng" algn="ctr">
                       <a:noFill/>
                     </a:lnL>
@@ -1680,7 +1486,7 @@
                     <a:bodyPr/>
                     <a:lstStyle/>
                     <a:p>
-                      <a:pPr indent="0" marL="0">
+                      <a:pPr marL="0" indent="0">
                         <a:buNone/>
                       </a:pPr>
                       <a:r>
@@ -1694,7 +1500,7 @@
                       <a:endParaRPr lang="en-US" sz="1600" dirty="0"/>
                     </a:p>
                   </a:txBody>
-                  <a:tcPr marL="91440" marR="91440" marT="45720" marB="45720">
+                  <a:tcPr>
                     <a:lnL w="0" cap="flat" cmpd="sng" algn="ctr">
                       <a:noFill/>
                     </a:lnL>
@@ -1709,6 +1515,11 @@
                     </a:lnB>
                   </a:tcPr>
                 </a:tc>
+                <a:extLst>
+                  <a:ext uri="{0D108BD9-81ED-4DB2-BD59-A6C34878D82A}">
+                    <a16:rowId xmlns:a16="http://schemas.microsoft.com/office/drawing/2014/main" val="10002"/>
+                  </a:ext>
+                </a:extLst>
               </a:tr>
               <a:tr h="0">
                 <a:tc>
@@ -1716,7 +1527,7 @@
                     <a:bodyPr/>
                     <a:lstStyle/>
                     <a:p>
-                      <a:pPr indent="0" marL="0">
+                      <a:pPr marL="0" indent="0">
                         <a:buNone/>
                       </a:pPr>
                       <a:r>
@@ -1730,7 +1541,7 @@
                       <a:endParaRPr lang="en-US" sz="1600" dirty="0"/>
                     </a:p>
                   </a:txBody>
-                  <a:tcPr marL="91440" marR="91440" marT="45720" marB="45720">
+                  <a:tcPr>
                     <a:lnL w="0" cap="flat" cmpd="sng" algn="ctr">
                       <a:noFill/>
                     </a:lnL>
@@ -1750,7 +1561,7 @@
                     <a:bodyPr/>
                     <a:lstStyle/>
                     <a:p>
-                      <a:pPr indent="0" marL="0">
+                      <a:pPr marL="0" indent="0">
                         <a:buNone/>
                       </a:pPr>
                       <a:r>
@@ -1764,7 +1575,7 @@
                       <a:endParaRPr lang="en-US" sz="1600" dirty="0"/>
                     </a:p>
                   </a:txBody>
-                  <a:tcPr marL="91440" marR="91440" marT="45720" marB="45720">
+                  <a:tcPr>
                     <a:lnL w="0" cap="flat" cmpd="sng" algn="ctr">
                       <a:noFill/>
                     </a:lnL>
@@ -1784,7 +1595,7 @@
                     <a:bodyPr/>
                     <a:lstStyle/>
                     <a:p>
-                      <a:pPr indent="0" marL="0">
+                      <a:pPr marL="0" indent="0">
                         <a:buNone/>
                       </a:pPr>
                       <a:r>
@@ -1798,7 +1609,7 @@
                       <a:endParaRPr lang="en-US" sz="1600" dirty="0"/>
                     </a:p>
                   </a:txBody>
-                  <a:tcPr marL="91440" marR="91440" marT="45720" marB="45720">
+                  <a:tcPr>
                     <a:lnL w="0" cap="flat" cmpd="sng" algn="ctr">
                       <a:noFill/>
                     </a:lnL>
@@ -1818,7 +1629,7 @@
                     <a:bodyPr/>
                     <a:lstStyle/>
                     <a:p>
-                      <a:pPr indent="0" marL="0">
+                      <a:pPr marL="0" indent="0">
                         <a:buNone/>
                       </a:pPr>
                       <a:r>
@@ -1832,7 +1643,7 @@
                       <a:endParaRPr lang="en-US" sz="1600" dirty="0"/>
                     </a:p>
                   </a:txBody>
-                  <a:tcPr marL="91440" marR="91440" marT="45720" marB="45720">
+                  <a:tcPr>
                     <a:lnL w="0" cap="flat" cmpd="sng" algn="ctr">
                       <a:noFill/>
                     </a:lnL>
@@ -1847,6 +1658,11 @@
                     </a:lnB>
                   </a:tcPr>
                 </a:tc>
+                <a:extLst>
+                  <a:ext uri="{0D108BD9-81ED-4DB2-BD59-A6C34878D82A}">
+                    <a16:rowId xmlns:a16="http://schemas.microsoft.com/office/drawing/2014/main" val="10003"/>
+                  </a:ext>
+                </a:extLst>
               </a:tr>
             </a:tbl>
           </a:graphicData>
@@ -1898,7 +1714,7 @@
           <a:bodyPr wrap="square" rtlCol="0" anchor="ctr"/>
           <a:lstStyle/>
           <a:p>
-            <a:pPr indent="0" marL="0">
+            <a:pPr marL="0" indent="0">
               <a:buNone/>
             </a:pPr>
             <a:r>
@@ -1915,14 +1731,14 @@
       </p:sp>
       <p:pic>
         <p:nvPicPr>
-          <p:cNvPr id="3" name="Image 0" descr="preencoded.png">    </p:cNvPr>
+          <p:cNvPr id="3" name="Image 0" descr="preencoded.png"/>
           <p:cNvPicPr>
             <a:picLocks noChangeAspect="1"/>
           </p:cNvPicPr>
           <p:nvPr/>
         </p:nvPicPr>
         <p:blipFill>
-          <a:blip r:embed="rId1"/>
+          <a:blip r:embed="rId3"/>
           <a:stretch>
             <a:fillRect/>
           </a:stretch>
@@ -1958,7 +1774,7 @@
           <a:bodyPr wrap="square" rtlCol="0" anchor="ctr"/>
           <a:lstStyle/>
           <a:p>
-            <a:pPr indent="0" marL="0">
+            <a:pPr marL="0" indent="0">
               <a:buNone/>
             </a:pPr>
             <a:r>
@@ -2019,7 +1835,7 @@
           <a:bodyPr wrap="square" rtlCol="0" anchor="ctr"/>
           <a:lstStyle/>
           <a:p>
-            <a:pPr indent="0" marL="0">
+            <a:pPr marL="0" indent="0">
               <a:buNone/>
             </a:pPr>
             <a:r>
@@ -2036,14 +1852,14 @@
       </p:sp>
       <p:pic>
         <p:nvPicPr>
-          <p:cNvPr id="3" name="Image 0" descr="preencoded.png">    </p:cNvPr>
+          <p:cNvPr id="3" name="Image 0" descr="preencoded.png"/>
           <p:cNvPicPr>
             <a:picLocks noChangeAspect="1"/>
           </p:cNvPicPr>
           <p:nvPr/>
         </p:nvPicPr>
         <p:blipFill>
-          <a:blip r:embed="rId1"/>
+          <a:blip r:embed="rId3"/>
           <a:stretch>
             <a:fillRect/>
           </a:stretch>
@@ -2059,6 +1875,2232 @@
         </p:spPr>
       </p:pic>
     </p:spTree>
+  </p:cSld>
+  <p:clrMapOvr>
+    <a:masterClrMapping/>
+  </p:clrMapOvr>
+</p:sld>
+</file>
+
+<file path=ppt/slides/slide5.xml><?xml version="1.0" encoding="utf-8"?>
+<p:sld xmlns:a="http://schemas.openxmlformats.org/drawingml/2006/main" xmlns:r="http://schemas.openxmlformats.org/officeDocument/2006/relationships" xmlns:p="http://schemas.openxmlformats.org/presentationml/2006/main">
+  <p:cSld>
+    <p:spTree>
+      <p:nvGrpSpPr>
+        <p:cNvPr id="1" name=""/>
+        <p:cNvGrpSpPr/>
+        <p:nvPr/>
+      </p:nvGrpSpPr>
+      <p:grpSpPr>
+        <a:xfrm>
+          <a:off x="0" y="0"/>
+          <a:ext cx="0" cy="0"/>
+          <a:chOff x="0" y="0"/>
+          <a:chExt cx="0" cy="0"/>
+        </a:xfrm>
+      </p:grpSpPr>
+      <p:sp>
+        <p:nvSpPr>
+          <p:cNvPr id="11" name="テキスト ボックス 10">
+            <a:extLst>
+              <a:ext uri="{FF2B5EF4-FFF2-40B4-BE49-F238E27FC236}">
+                <a16:creationId xmlns:a16="http://schemas.microsoft.com/office/drawing/2014/main" id="{08B243AC-4B57-7457-E8D6-A9A89CD1B92F}"/>
+              </a:ext>
+            </a:extLst>
+          </p:cNvPr>
+          <p:cNvSpPr txBox="1"/>
+          <p:nvPr/>
+        </p:nvSpPr>
+        <p:spPr>
+          <a:xfrm>
+            <a:off x="801585" y="564079"/>
+            <a:ext cx="6774873" cy="2846933"/>
+          </a:xfrm>
+          <a:prstGeom prst="rect">
+            <a:avLst/>
+          </a:prstGeom>
+          <a:noFill/>
+        </p:spPr>
+        <p:txBody>
+          <a:bodyPr wrap="square">
+            <a:spAutoFit/>
+          </a:bodyPr>
+          <a:lstStyle/>
+          <a:p>
+            <a:pPr>
+              <a:buNone/>
+            </a:pPr>
+            <a:r>
+              <a:rPr lang="ja-JP" altLang="ja-JP" sz="1600" b="1" kern="0" dirty="0">
+                <a:solidFill>
+                  <a:srgbClr val="2E74B5"/>
+                </a:solidFill>
+                <a:effectLst/>
+                <a:latin typeface="Times New Roman" panose="02020603050405020304" pitchFamily="18" charset="0"/>
+                <a:ea typeface="游明朝" panose="02020400000000000000" pitchFamily="18" charset="-128"/>
+              </a:rPr>
+              <a:t>月次売上レポート</a:t>
+            </a:r>
+            <a:endParaRPr lang="ja-JP" altLang="ja-JP" sz="1600" b="1" kern="0" dirty="0">
+              <a:solidFill>
+                <a:srgbClr val="2E74B5"/>
+              </a:solidFill>
+              <a:effectLst/>
+              <a:latin typeface="Times New Roman" panose="02020603050405020304" pitchFamily="18" charset="0"/>
+            </a:endParaRPr>
+          </a:p>
+          <a:p>
+            <a:pPr>
+              <a:buNone/>
+            </a:pPr>
+            <a:r>
+              <a:rPr lang="ja-JP" altLang="ja-JP" sz="1000" dirty="0">
+                <a:effectLst/>
+                <a:latin typeface="Times New Roman" panose="02020603050405020304" pitchFamily="18" charset="0"/>
+                <a:ea typeface="游明朝" panose="02020400000000000000" pitchFamily="18" charset="-128"/>
+              </a:rPr>
+              <a:t>このドキュメントは</a:t>
+            </a:r>
+            <a:r>
+              <a:rPr lang="en-US" altLang="ja-JP" sz="1000" dirty="0">
+                <a:effectLst/>
+                <a:latin typeface="Times New Roman" panose="02020603050405020304" pitchFamily="18" charset="0"/>
+                <a:ea typeface="游明朝" panose="02020400000000000000" pitchFamily="18" charset="-128"/>
+              </a:rPr>
+              <a:t> docx → markdown </a:t>
+            </a:r>
+            <a:r>
+              <a:rPr lang="ja-JP" altLang="ja-JP" sz="1000" dirty="0">
+                <a:effectLst/>
+                <a:latin typeface="Times New Roman" panose="02020603050405020304" pitchFamily="18" charset="0"/>
+                <a:ea typeface="游明朝" panose="02020400000000000000" pitchFamily="18" charset="-128"/>
+              </a:rPr>
+              <a:t>変換のテスト用に作成されたサンプルです。表と画像を含みます。</a:t>
+            </a:r>
+          </a:p>
+          <a:p>
+            <a:pPr>
+              <a:buNone/>
+            </a:pPr>
+            <a:r>
+              <a:rPr lang="en-US" altLang="ja-JP" sz="1000" dirty="0">
+                <a:effectLst/>
+                <a:latin typeface="Times New Roman" panose="02020603050405020304" pitchFamily="18" charset="0"/>
+                <a:ea typeface="游明朝" panose="02020400000000000000" pitchFamily="18" charset="-128"/>
+              </a:rPr>
+              <a:t> </a:t>
+            </a:r>
+            <a:endParaRPr lang="ja-JP" altLang="ja-JP" sz="1000" dirty="0">
+              <a:effectLst/>
+              <a:latin typeface="Times New Roman" panose="02020603050405020304" pitchFamily="18" charset="0"/>
+              <a:ea typeface="游明朝" panose="02020400000000000000" pitchFamily="18" charset="-128"/>
+            </a:endParaRPr>
+          </a:p>
+          <a:p>
+            <a:pPr marL="342900" lvl="0" indent="-342900">
+              <a:buFont typeface="Wingdings" panose="05000000000000000000" pitchFamily="2" charset="2"/>
+              <a:buChar char=""/>
+            </a:pPr>
+            <a:r>
+              <a:rPr lang="ja-JP" altLang="ja-JP" sz="1000" dirty="0">
+                <a:effectLst/>
+                <a:latin typeface="Times New Roman" panose="02020603050405020304" pitchFamily="18" charset="0"/>
+                <a:ea typeface="游明朝" panose="02020400000000000000" pitchFamily="18" charset="-128"/>
+              </a:rPr>
+              <a:t>これは</a:t>
+            </a:r>
+          </a:p>
+          <a:p>
+            <a:pPr marL="742950" lvl="1" indent="-285750">
+              <a:buFont typeface="Wingdings" panose="05000000000000000000" pitchFamily="2" charset="2"/>
+              <a:buChar char=""/>
+            </a:pPr>
+            <a:r>
+              <a:rPr lang="ja-JP" altLang="ja-JP" sz="1000" dirty="0">
+                <a:effectLst/>
+                <a:latin typeface="Times New Roman" panose="02020603050405020304" pitchFamily="18" charset="0"/>
+                <a:ea typeface="游明朝" panose="02020400000000000000" pitchFamily="18" charset="-128"/>
+              </a:rPr>
+              <a:t>とても</a:t>
+            </a:r>
+          </a:p>
+          <a:p>
+            <a:pPr marL="1143000" lvl="2" indent="-228600">
+              <a:buFont typeface="Wingdings" panose="05000000000000000000" pitchFamily="2" charset="2"/>
+              <a:buChar char=""/>
+            </a:pPr>
+            <a:r>
+              <a:rPr lang="ja-JP" altLang="ja-JP" sz="1000" dirty="0">
+                <a:effectLst/>
+                <a:latin typeface="Times New Roman" panose="02020603050405020304" pitchFamily="18" charset="0"/>
+                <a:ea typeface="游明朝" panose="02020400000000000000" pitchFamily="18" charset="-128"/>
+              </a:rPr>
+              <a:t>だいじ</a:t>
+            </a:r>
+          </a:p>
+          <a:p>
+            <a:pPr marL="742950" lvl="1" indent="-285750">
+              <a:buFont typeface="Wingdings" panose="05000000000000000000" pitchFamily="2" charset="2"/>
+              <a:buChar char=""/>
+            </a:pPr>
+            <a:r>
+              <a:rPr lang="ja-JP" altLang="ja-JP" sz="1000" dirty="0">
+                <a:effectLst/>
+                <a:latin typeface="Times New Roman" panose="02020603050405020304" pitchFamily="18" charset="0"/>
+                <a:ea typeface="游明朝" panose="02020400000000000000" pitchFamily="18" charset="-128"/>
+              </a:rPr>
+              <a:t>かも</a:t>
+            </a:r>
+          </a:p>
+          <a:p>
+            <a:pPr marL="342900" lvl="0" indent="-342900">
+              <a:buFont typeface="Wingdings" panose="05000000000000000000" pitchFamily="2" charset="2"/>
+              <a:buChar char=""/>
+            </a:pPr>
+            <a:r>
+              <a:rPr lang="ja-JP" altLang="ja-JP" sz="1000" dirty="0">
+                <a:effectLst/>
+                <a:latin typeface="Times New Roman" panose="02020603050405020304" pitchFamily="18" charset="0"/>
+                <a:ea typeface="游明朝" panose="02020400000000000000" pitchFamily="18" charset="-128"/>
+              </a:rPr>
+              <a:t>しれない</a:t>
+            </a:r>
+          </a:p>
+          <a:p>
+            <a:pPr marL="742950" lvl="1" indent="-285750">
+              <a:buFont typeface="Wingdings" panose="05000000000000000000" pitchFamily="2" charset="2"/>
+              <a:buChar char=""/>
+            </a:pPr>
+            <a:r>
+              <a:rPr lang="ja-JP" altLang="ja-JP" sz="1000" dirty="0">
+                <a:effectLst/>
+                <a:latin typeface="Times New Roman" panose="02020603050405020304" pitchFamily="18" charset="0"/>
+                <a:ea typeface="游明朝" panose="02020400000000000000" pitchFamily="18" charset="-128"/>
+              </a:rPr>
+              <a:t>ね</a:t>
+            </a:r>
+          </a:p>
+          <a:p>
+            <a:pPr>
+              <a:buNone/>
+            </a:pPr>
+            <a:r>
+              <a:rPr lang="en-US" altLang="ja-JP" sz="1000" dirty="0">
+                <a:effectLst/>
+                <a:latin typeface="Times New Roman" panose="02020603050405020304" pitchFamily="18" charset="0"/>
+                <a:ea typeface="游明朝" panose="02020400000000000000" pitchFamily="18" charset="-128"/>
+              </a:rPr>
+              <a:t> </a:t>
+            </a:r>
+            <a:endParaRPr lang="ja-JP" altLang="ja-JP" sz="1000" dirty="0">
+              <a:effectLst/>
+              <a:latin typeface="Times New Roman" panose="02020603050405020304" pitchFamily="18" charset="0"/>
+              <a:ea typeface="游明朝" panose="02020400000000000000" pitchFamily="18" charset="-128"/>
+            </a:endParaRPr>
+          </a:p>
+          <a:p>
+            <a:pPr>
+              <a:buNone/>
+            </a:pPr>
+            <a:r>
+              <a:rPr lang="ja-JP" altLang="ja-JP" sz="1300" b="1" dirty="0">
+                <a:solidFill>
+                  <a:srgbClr val="2E74B5"/>
+                </a:solidFill>
+                <a:effectLst/>
+                <a:latin typeface="Times New Roman" panose="02020603050405020304" pitchFamily="18" charset="0"/>
+                <a:ea typeface="游明朝" panose="02020400000000000000" pitchFamily="18" charset="-128"/>
+              </a:rPr>
+              <a:t>見出し</a:t>
+            </a:r>
+            <a:r>
+              <a:rPr lang="en-US" altLang="ja-JP" sz="1300" b="1" dirty="0">
+                <a:solidFill>
+                  <a:srgbClr val="2E74B5"/>
+                </a:solidFill>
+                <a:effectLst/>
+                <a:latin typeface="Times New Roman" panose="02020603050405020304" pitchFamily="18" charset="0"/>
+              </a:rPr>
+              <a:t>2</a:t>
+            </a:r>
+            <a:endParaRPr lang="ja-JP" altLang="ja-JP" sz="1300" b="1" dirty="0">
+              <a:solidFill>
+                <a:srgbClr val="2E74B5"/>
+              </a:solidFill>
+              <a:effectLst/>
+              <a:latin typeface="Times New Roman" panose="02020603050405020304" pitchFamily="18" charset="0"/>
+            </a:endParaRPr>
+          </a:p>
+          <a:p>
+            <a:pPr>
+              <a:buNone/>
+            </a:pPr>
+            <a:r>
+              <a:rPr lang="en-US" altLang="ja-JP" sz="1000" dirty="0">
+                <a:effectLst/>
+                <a:latin typeface="Times New Roman" panose="02020603050405020304" pitchFamily="18" charset="0"/>
+                <a:ea typeface="游明朝" panose="02020400000000000000" pitchFamily="18" charset="-128"/>
+              </a:rPr>
+              <a:t> </a:t>
+            </a:r>
+            <a:endParaRPr lang="ja-JP" altLang="ja-JP" sz="1000" dirty="0">
+              <a:effectLst/>
+              <a:latin typeface="Times New Roman" panose="02020603050405020304" pitchFamily="18" charset="0"/>
+              <a:ea typeface="游明朝" panose="02020400000000000000" pitchFamily="18" charset="-128"/>
+            </a:endParaRPr>
+          </a:p>
+          <a:p>
+            <a:pPr marL="342900" lvl="0" indent="-342900">
+              <a:buFont typeface="+mj-lt"/>
+              <a:buAutoNum type="arabicPeriod"/>
+            </a:pPr>
+            <a:r>
+              <a:rPr lang="ja-JP" altLang="ja-JP" sz="1000" dirty="0">
+                <a:effectLst/>
+                <a:latin typeface="Times New Roman" panose="02020603050405020304" pitchFamily="18" charset="0"/>
+                <a:ea typeface="游明朝" panose="02020400000000000000" pitchFamily="18" charset="-128"/>
+              </a:rPr>
+              <a:t>いちご</a:t>
+            </a:r>
+          </a:p>
+          <a:p>
+            <a:pPr marL="742950" lvl="1" indent="-285750">
+              <a:buFont typeface="+mj-ea"/>
+              <a:buAutoNum type="ea1ChsPlain"/>
+            </a:pPr>
+            <a:r>
+              <a:rPr lang="ja-JP" altLang="ja-JP" sz="1000" dirty="0">
+                <a:effectLst/>
+                <a:latin typeface="Times New Roman" panose="02020603050405020304" pitchFamily="18" charset="0"/>
+                <a:ea typeface="游明朝" panose="02020400000000000000" pitchFamily="18" charset="-128"/>
+              </a:rPr>
+              <a:t>りんご</a:t>
+            </a:r>
+          </a:p>
+          <a:p>
+            <a:pPr marL="1143000" lvl="2" indent="-228600">
+              <a:buFont typeface="+mj-ea"/>
+              <a:buAutoNum type="circleNumDbPlain"/>
+            </a:pPr>
+            <a:r>
+              <a:rPr lang="ja-JP" altLang="ja-JP" sz="1000" dirty="0">
+                <a:effectLst/>
+                <a:latin typeface="Times New Roman" panose="02020603050405020304" pitchFamily="18" charset="0"/>
+                <a:ea typeface="游明朝" panose="02020400000000000000" pitchFamily="18" charset="-128"/>
+              </a:rPr>
+              <a:t>ばなな</a:t>
+            </a:r>
+          </a:p>
+          <a:p>
+            <a:pPr marL="342900" lvl="0" indent="-342900">
+              <a:buFont typeface="+mj-lt"/>
+              <a:buAutoNum type="arabicPeriod"/>
+            </a:pPr>
+            <a:r>
+              <a:rPr lang="ja-JP" altLang="ja-JP" sz="1000" dirty="0">
+                <a:effectLst/>
+                <a:latin typeface="Times New Roman" panose="02020603050405020304" pitchFamily="18" charset="0"/>
+                <a:ea typeface="游明朝" panose="02020400000000000000" pitchFamily="18" charset="-128"/>
+              </a:rPr>
+              <a:t>りんご</a:t>
+            </a:r>
+          </a:p>
+          <a:p>
+            <a:pPr marL="742950" lvl="1" indent="-285750">
+              <a:buFont typeface="+mj-ea"/>
+              <a:buAutoNum type="ea1ChsPlain"/>
+            </a:pPr>
+            <a:r>
+              <a:rPr lang="ja-JP" altLang="ja-JP" sz="1000" dirty="0">
+                <a:effectLst/>
+                <a:latin typeface="Times New Roman" panose="02020603050405020304" pitchFamily="18" charset="0"/>
+                <a:ea typeface="游明朝" panose="02020400000000000000" pitchFamily="18" charset="-128"/>
+              </a:rPr>
+              <a:t>ばなな</a:t>
+            </a:r>
+          </a:p>
+        </p:txBody>
+      </p:sp>
+    </p:spTree>
+    <p:extLst>
+      <p:ext uri="{BB962C8B-B14F-4D97-AF65-F5344CB8AC3E}">
+        <p14:creationId xmlns:p14="http://schemas.microsoft.com/office/powerpoint/2010/main" val="1499793188"/>
+      </p:ext>
+    </p:extLst>
+  </p:cSld>
+  <p:clrMapOvr>
+    <a:masterClrMapping/>
+  </p:clrMapOvr>
+</p:sld>
+</file>
+
+<file path=ppt/slides/slide6.xml><?xml version="1.0" encoding="utf-8"?>
+<p:sld xmlns:a="http://schemas.openxmlformats.org/drawingml/2006/main" xmlns:r="http://schemas.openxmlformats.org/officeDocument/2006/relationships" xmlns:p="http://schemas.openxmlformats.org/presentationml/2006/main">
+  <p:cSld>
+    <p:spTree>
+      <p:nvGrpSpPr>
+        <p:cNvPr id="1" name=""/>
+        <p:cNvGrpSpPr/>
+        <p:nvPr/>
+      </p:nvGrpSpPr>
+      <p:grpSpPr>
+        <a:xfrm>
+          <a:off x="0" y="0"/>
+          <a:ext cx="0" cy="0"/>
+          <a:chOff x="0" y="0"/>
+          <a:chExt cx="0" cy="0"/>
+        </a:xfrm>
+      </p:grpSpPr>
+      <p:graphicFrame>
+        <p:nvGraphicFramePr>
+          <p:cNvPr id="6" name="表 5">
+            <a:extLst>
+              <a:ext uri="{FF2B5EF4-FFF2-40B4-BE49-F238E27FC236}">
+                <a16:creationId xmlns:a16="http://schemas.microsoft.com/office/drawing/2014/main" id="{CACFB22F-784C-15D9-CC05-0D526DE4DE07}"/>
+              </a:ext>
+            </a:extLst>
+          </p:cNvPr>
+          <p:cNvGraphicFramePr>
+            <a:graphicFrameLocks noGrp="1"/>
+          </p:cNvGraphicFramePr>
+          <p:nvPr/>
+        </p:nvGraphicFramePr>
+        <p:xfrm>
+          <a:off x="628650" y="1370013"/>
+          <a:ext cx="7886700" cy="1219200"/>
+        </p:xfrm>
+        <a:graphic>
+          <a:graphicData uri="http://schemas.openxmlformats.org/drawingml/2006/table">
+            <a:tbl>
+              <a:tblPr/>
+              <a:tblGrid>
+                <a:gridCol w="1971675">
+                  <a:extLst>
+                    <a:ext uri="{9D8B030D-6E8A-4147-A177-3AD203B41FA5}">
+                      <a16:colId xmlns:a16="http://schemas.microsoft.com/office/drawing/2014/main" val="1508176782"/>
+                    </a:ext>
+                  </a:extLst>
+                </a:gridCol>
+                <a:gridCol w="1971675">
+                  <a:extLst>
+                    <a:ext uri="{9D8B030D-6E8A-4147-A177-3AD203B41FA5}">
+                      <a16:colId xmlns:a16="http://schemas.microsoft.com/office/drawing/2014/main" val="4128019237"/>
+                    </a:ext>
+                  </a:extLst>
+                </a:gridCol>
+                <a:gridCol w="1971675">
+                  <a:extLst>
+                    <a:ext uri="{9D8B030D-6E8A-4147-A177-3AD203B41FA5}">
+                      <a16:colId xmlns:a16="http://schemas.microsoft.com/office/drawing/2014/main" val="3256567044"/>
+                    </a:ext>
+                  </a:extLst>
+                </a:gridCol>
+                <a:gridCol w="1971675">
+                  <a:extLst>
+                    <a:ext uri="{9D8B030D-6E8A-4147-A177-3AD203B41FA5}">
+                      <a16:colId xmlns:a16="http://schemas.microsoft.com/office/drawing/2014/main" val="1612480964"/>
+                    </a:ext>
+                  </a:extLst>
+                </a:gridCol>
+              </a:tblGrid>
+              <a:tr h="0">
+                <a:tc>
+                  <a:txBody>
+                    <a:bodyPr/>
+                    <a:lstStyle/>
+                    <a:p>
+                      <a:pPr>
+                        <a:buNone/>
+                      </a:pPr>
+                      <a:r>
+                        <a:rPr lang="ja-JP" sz="1000" b="1">
+                          <a:effectLst/>
+                          <a:latin typeface="Times New Roman" panose="02020603050405020304" pitchFamily="18" charset="0"/>
+                          <a:ea typeface="游明朝" panose="02020400000000000000" pitchFamily="18" charset="-128"/>
+                        </a:rPr>
+                        <a:t>商品名</a:t>
+                      </a:r>
+                      <a:endParaRPr lang="ja-JP" sz="1000">
+                        <a:effectLst/>
+                        <a:latin typeface="Times New Roman" panose="02020603050405020304" pitchFamily="18" charset="0"/>
+                        <a:ea typeface="游明朝" panose="02020400000000000000" pitchFamily="18" charset="-128"/>
+                      </a:endParaRPr>
+                    </a:p>
+                    <a:p>
+                      <a:pPr>
+                        <a:buNone/>
+                      </a:pPr>
+                      <a:endParaRPr lang="ja-JP" sz="1000">
+                        <a:effectLst/>
+                        <a:latin typeface="Times New Roman" panose="02020603050405020304" pitchFamily="18" charset="0"/>
+                      </a:endParaRPr>
+                    </a:p>
+                  </a:txBody>
+                  <a:tcPr marL="6350" marR="6350" marT="0" marB="0">
+                    <a:lnL w="12700" cap="flat" cmpd="sng" algn="ctr">
+                      <a:solidFill>
+                        <a:srgbClr val="000000"/>
+                      </a:solidFill>
+                      <a:prstDash val="solid"/>
+                      <a:round/>
+                      <a:headEnd type="none" w="med" len="med"/>
+                      <a:tailEnd type="none" w="med" len="med"/>
+                    </a:lnL>
+                    <a:lnR w="12700" cap="flat" cmpd="sng" algn="ctr">
+                      <a:solidFill>
+                        <a:srgbClr val="000000"/>
+                      </a:solidFill>
+                      <a:prstDash val="solid"/>
+                      <a:round/>
+                      <a:headEnd type="none" w="med" len="med"/>
+                      <a:tailEnd type="none" w="med" len="med"/>
+                    </a:lnR>
+                    <a:lnT w="12700" cap="flat" cmpd="sng" algn="ctr">
+                      <a:solidFill>
+                        <a:srgbClr val="000000"/>
+                      </a:solidFill>
+                      <a:prstDash val="solid"/>
+                      <a:round/>
+                      <a:headEnd type="none" w="med" len="med"/>
+                      <a:tailEnd type="none" w="med" len="med"/>
+                    </a:lnT>
+                    <a:lnB w="12700" cap="flat" cmpd="sng" algn="ctr">
+                      <a:solidFill>
+                        <a:srgbClr val="000000"/>
+                      </a:solidFill>
+                      <a:prstDash val="solid"/>
+                      <a:round/>
+                      <a:headEnd type="none" w="med" len="med"/>
+                      <a:tailEnd type="none" w="med" len="med"/>
+                    </a:lnB>
+                    <a:noFill/>
+                  </a:tcPr>
+                </a:tc>
+                <a:tc>
+                  <a:txBody>
+                    <a:bodyPr/>
+                    <a:lstStyle/>
+                    <a:p>
+                      <a:pPr>
+                        <a:buNone/>
+                      </a:pPr>
+                      <a:r>
+                        <a:rPr lang="ja-JP" sz="1000" b="1">
+                          <a:effectLst/>
+                          <a:latin typeface="Times New Roman" panose="02020603050405020304" pitchFamily="18" charset="0"/>
+                          <a:ea typeface="游明朝" panose="02020400000000000000" pitchFamily="18" charset="-128"/>
+                        </a:rPr>
+                        <a:t>数量</a:t>
+                      </a:r>
+                      <a:endParaRPr lang="ja-JP" sz="1000">
+                        <a:effectLst/>
+                        <a:latin typeface="Times New Roman" panose="02020603050405020304" pitchFamily="18" charset="0"/>
+                        <a:ea typeface="游明朝" panose="02020400000000000000" pitchFamily="18" charset="-128"/>
+                      </a:endParaRPr>
+                    </a:p>
+                    <a:p>
+                      <a:pPr>
+                        <a:buNone/>
+                      </a:pPr>
+                      <a:endParaRPr lang="ja-JP" sz="1000">
+                        <a:effectLst/>
+                        <a:latin typeface="Times New Roman" panose="02020603050405020304" pitchFamily="18" charset="0"/>
+                      </a:endParaRPr>
+                    </a:p>
+                  </a:txBody>
+                  <a:tcPr marL="6350" marR="6350" marT="0" marB="0">
+                    <a:lnL w="12700" cap="flat" cmpd="sng" algn="ctr">
+                      <a:solidFill>
+                        <a:srgbClr val="000000"/>
+                      </a:solidFill>
+                      <a:prstDash val="solid"/>
+                      <a:round/>
+                      <a:headEnd type="none" w="med" len="med"/>
+                      <a:tailEnd type="none" w="med" len="med"/>
+                    </a:lnL>
+                    <a:lnR w="12700" cap="flat" cmpd="sng" algn="ctr">
+                      <a:solidFill>
+                        <a:srgbClr val="000000"/>
+                      </a:solidFill>
+                      <a:prstDash val="solid"/>
+                      <a:round/>
+                      <a:headEnd type="none" w="med" len="med"/>
+                      <a:tailEnd type="none" w="med" len="med"/>
+                    </a:lnR>
+                    <a:lnT w="12700" cap="flat" cmpd="sng" algn="ctr">
+                      <a:solidFill>
+                        <a:srgbClr val="000000"/>
+                      </a:solidFill>
+                      <a:prstDash val="solid"/>
+                      <a:round/>
+                      <a:headEnd type="none" w="med" len="med"/>
+                      <a:tailEnd type="none" w="med" len="med"/>
+                    </a:lnT>
+                    <a:lnB w="12700" cap="flat" cmpd="sng" algn="ctr">
+                      <a:solidFill>
+                        <a:srgbClr val="000000"/>
+                      </a:solidFill>
+                      <a:prstDash val="solid"/>
+                      <a:round/>
+                      <a:headEnd type="none" w="med" len="med"/>
+                      <a:tailEnd type="none" w="med" len="med"/>
+                    </a:lnB>
+                    <a:noFill/>
+                  </a:tcPr>
+                </a:tc>
+                <a:tc>
+                  <a:txBody>
+                    <a:bodyPr/>
+                    <a:lstStyle/>
+                    <a:p>
+                      <a:pPr>
+                        <a:buNone/>
+                      </a:pPr>
+                      <a:r>
+                        <a:rPr lang="ja-JP" sz="1000" b="1">
+                          <a:effectLst/>
+                          <a:latin typeface="Times New Roman" panose="02020603050405020304" pitchFamily="18" charset="0"/>
+                          <a:ea typeface="游明朝" panose="02020400000000000000" pitchFamily="18" charset="-128"/>
+                        </a:rPr>
+                        <a:t>単価</a:t>
+                      </a:r>
+                      <a:endParaRPr lang="ja-JP" sz="1000">
+                        <a:effectLst/>
+                        <a:latin typeface="Times New Roman" panose="02020603050405020304" pitchFamily="18" charset="0"/>
+                        <a:ea typeface="游明朝" panose="02020400000000000000" pitchFamily="18" charset="-128"/>
+                      </a:endParaRPr>
+                    </a:p>
+                    <a:p>
+                      <a:pPr>
+                        <a:buNone/>
+                      </a:pPr>
+                      <a:endParaRPr lang="ja-JP" sz="1000">
+                        <a:effectLst/>
+                        <a:latin typeface="Times New Roman" panose="02020603050405020304" pitchFamily="18" charset="0"/>
+                      </a:endParaRPr>
+                    </a:p>
+                  </a:txBody>
+                  <a:tcPr marL="6350" marR="6350" marT="0" marB="0">
+                    <a:lnL w="12700" cap="flat" cmpd="sng" algn="ctr">
+                      <a:solidFill>
+                        <a:srgbClr val="000000"/>
+                      </a:solidFill>
+                      <a:prstDash val="solid"/>
+                      <a:round/>
+                      <a:headEnd type="none" w="med" len="med"/>
+                      <a:tailEnd type="none" w="med" len="med"/>
+                    </a:lnL>
+                    <a:lnR w="12700" cap="flat" cmpd="sng" algn="ctr">
+                      <a:solidFill>
+                        <a:srgbClr val="000000"/>
+                      </a:solidFill>
+                      <a:prstDash val="solid"/>
+                      <a:round/>
+                      <a:headEnd type="none" w="med" len="med"/>
+                      <a:tailEnd type="none" w="med" len="med"/>
+                    </a:lnR>
+                    <a:lnT w="12700" cap="flat" cmpd="sng" algn="ctr">
+                      <a:solidFill>
+                        <a:srgbClr val="000000"/>
+                      </a:solidFill>
+                      <a:prstDash val="solid"/>
+                      <a:round/>
+                      <a:headEnd type="none" w="med" len="med"/>
+                      <a:tailEnd type="none" w="med" len="med"/>
+                    </a:lnT>
+                    <a:lnB w="12700" cap="flat" cmpd="sng" algn="ctr">
+                      <a:solidFill>
+                        <a:srgbClr val="000000"/>
+                      </a:solidFill>
+                      <a:prstDash val="solid"/>
+                      <a:round/>
+                      <a:headEnd type="none" w="med" len="med"/>
+                      <a:tailEnd type="none" w="med" len="med"/>
+                    </a:lnB>
+                    <a:noFill/>
+                  </a:tcPr>
+                </a:tc>
+                <a:tc>
+                  <a:txBody>
+                    <a:bodyPr/>
+                    <a:lstStyle/>
+                    <a:p>
+                      <a:pPr>
+                        <a:buNone/>
+                      </a:pPr>
+                      <a:r>
+                        <a:rPr lang="ja-JP" sz="1000" b="1">
+                          <a:effectLst/>
+                          <a:latin typeface="Times New Roman" panose="02020603050405020304" pitchFamily="18" charset="0"/>
+                          <a:ea typeface="游明朝" panose="02020400000000000000" pitchFamily="18" charset="-128"/>
+                        </a:rPr>
+                        <a:t>合計</a:t>
+                      </a:r>
+                      <a:endParaRPr lang="ja-JP" sz="1000">
+                        <a:effectLst/>
+                        <a:latin typeface="Times New Roman" panose="02020603050405020304" pitchFamily="18" charset="0"/>
+                        <a:ea typeface="游明朝" panose="02020400000000000000" pitchFamily="18" charset="-128"/>
+                      </a:endParaRPr>
+                    </a:p>
+                    <a:p>
+                      <a:pPr>
+                        <a:buNone/>
+                      </a:pPr>
+                      <a:endParaRPr lang="ja-JP" sz="1000">
+                        <a:effectLst/>
+                        <a:latin typeface="Times New Roman" panose="02020603050405020304" pitchFamily="18" charset="0"/>
+                      </a:endParaRPr>
+                    </a:p>
+                  </a:txBody>
+                  <a:tcPr marL="6350" marR="6350" marT="0" marB="0">
+                    <a:lnL w="12700" cap="flat" cmpd="sng" algn="ctr">
+                      <a:solidFill>
+                        <a:srgbClr val="000000"/>
+                      </a:solidFill>
+                      <a:prstDash val="solid"/>
+                      <a:round/>
+                      <a:headEnd type="none" w="med" len="med"/>
+                      <a:tailEnd type="none" w="med" len="med"/>
+                    </a:lnL>
+                    <a:lnR w="12700" cap="flat" cmpd="sng" algn="ctr">
+                      <a:solidFill>
+                        <a:srgbClr val="000000"/>
+                      </a:solidFill>
+                      <a:prstDash val="solid"/>
+                      <a:round/>
+                      <a:headEnd type="none" w="med" len="med"/>
+                      <a:tailEnd type="none" w="med" len="med"/>
+                    </a:lnR>
+                    <a:lnT w="12700" cap="flat" cmpd="sng" algn="ctr">
+                      <a:solidFill>
+                        <a:srgbClr val="000000"/>
+                      </a:solidFill>
+                      <a:prstDash val="solid"/>
+                      <a:round/>
+                      <a:headEnd type="none" w="med" len="med"/>
+                      <a:tailEnd type="none" w="med" len="med"/>
+                    </a:lnT>
+                    <a:lnB w="12700" cap="flat" cmpd="sng" algn="ctr">
+                      <a:solidFill>
+                        <a:srgbClr val="000000"/>
+                      </a:solidFill>
+                      <a:prstDash val="solid"/>
+                      <a:round/>
+                      <a:headEnd type="none" w="med" len="med"/>
+                      <a:tailEnd type="none" w="med" len="med"/>
+                    </a:lnB>
+                    <a:noFill/>
+                  </a:tcPr>
+                </a:tc>
+                <a:extLst>
+                  <a:ext uri="{0D108BD9-81ED-4DB2-BD59-A6C34878D82A}">
+                    <a16:rowId xmlns:a16="http://schemas.microsoft.com/office/drawing/2014/main" val="873945345"/>
+                  </a:ext>
+                </a:extLst>
+              </a:tr>
+              <a:tr h="0">
+                <a:tc>
+                  <a:txBody>
+                    <a:bodyPr/>
+                    <a:lstStyle/>
+                    <a:p>
+                      <a:pPr>
+                        <a:buNone/>
+                      </a:pPr>
+                      <a:r>
+                        <a:rPr lang="ja-JP" sz="1000" dirty="0">
+                          <a:effectLst/>
+                          <a:latin typeface="Times New Roman" panose="02020603050405020304" pitchFamily="18" charset="0"/>
+                          <a:ea typeface="游明朝" panose="02020400000000000000" pitchFamily="18" charset="-128"/>
+                        </a:rPr>
+                        <a:t>りんご</a:t>
+                      </a:r>
+                    </a:p>
+                    <a:p>
+                      <a:pPr>
+                        <a:buNone/>
+                      </a:pPr>
+                      <a:endParaRPr lang="ja-JP" sz="1000" dirty="0">
+                        <a:effectLst/>
+                        <a:latin typeface="Times New Roman" panose="02020603050405020304" pitchFamily="18" charset="0"/>
+                      </a:endParaRPr>
+                    </a:p>
+                  </a:txBody>
+                  <a:tcPr marL="6350" marR="6350" marT="0" marB="0">
+                    <a:lnL w="12700" cap="flat" cmpd="sng" algn="ctr">
+                      <a:solidFill>
+                        <a:srgbClr val="000000"/>
+                      </a:solidFill>
+                      <a:prstDash val="solid"/>
+                      <a:round/>
+                      <a:headEnd type="none" w="med" len="med"/>
+                      <a:tailEnd type="none" w="med" len="med"/>
+                    </a:lnL>
+                    <a:lnR w="12700" cap="flat" cmpd="sng" algn="ctr">
+                      <a:solidFill>
+                        <a:srgbClr val="000000"/>
+                      </a:solidFill>
+                      <a:prstDash val="solid"/>
+                      <a:round/>
+                      <a:headEnd type="none" w="med" len="med"/>
+                      <a:tailEnd type="none" w="med" len="med"/>
+                    </a:lnR>
+                    <a:lnT w="12700" cap="flat" cmpd="sng" algn="ctr">
+                      <a:solidFill>
+                        <a:srgbClr val="000000"/>
+                      </a:solidFill>
+                      <a:prstDash val="solid"/>
+                      <a:round/>
+                      <a:headEnd type="none" w="med" len="med"/>
+                      <a:tailEnd type="none" w="med" len="med"/>
+                    </a:lnT>
+                    <a:lnB w="12700" cap="flat" cmpd="sng" algn="ctr">
+                      <a:solidFill>
+                        <a:srgbClr val="000000"/>
+                      </a:solidFill>
+                      <a:prstDash val="solid"/>
+                      <a:round/>
+                      <a:headEnd type="none" w="med" len="med"/>
+                      <a:tailEnd type="none" w="med" len="med"/>
+                    </a:lnB>
+                    <a:noFill/>
+                  </a:tcPr>
+                </a:tc>
+                <a:tc>
+                  <a:txBody>
+                    <a:bodyPr/>
+                    <a:lstStyle/>
+                    <a:p>
+                      <a:pPr>
+                        <a:buNone/>
+                      </a:pPr>
+                      <a:r>
+                        <a:rPr lang="en-US" sz="1000">
+                          <a:effectLst/>
+                          <a:latin typeface="Times New Roman" panose="02020603050405020304" pitchFamily="18" charset="0"/>
+                          <a:ea typeface="游明朝" panose="02020400000000000000" pitchFamily="18" charset="-128"/>
+                        </a:rPr>
+                        <a:t>3</a:t>
+                      </a:r>
+                      <a:endParaRPr lang="ja-JP" sz="1000">
+                        <a:effectLst/>
+                        <a:latin typeface="Times New Roman" panose="02020603050405020304" pitchFamily="18" charset="0"/>
+                        <a:ea typeface="游明朝" panose="02020400000000000000" pitchFamily="18" charset="-128"/>
+                      </a:endParaRPr>
+                    </a:p>
+                    <a:p>
+                      <a:pPr>
+                        <a:buNone/>
+                      </a:pPr>
+                      <a:endParaRPr lang="ja-JP" sz="1000">
+                        <a:effectLst/>
+                        <a:latin typeface="Times New Roman" panose="02020603050405020304" pitchFamily="18" charset="0"/>
+                      </a:endParaRPr>
+                    </a:p>
+                  </a:txBody>
+                  <a:tcPr marL="6350" marR="6350" marT="0" marB="0">
+                    <a:lnL w="12700" cap="flat" cmpd="sng" algn="ctr">
+                      <a:solidFill>
+                        <a:srgbClr val="000000"/>
+                      </a:solidFill>
+                      <a:prstDash val="solid"/>
+                      <a:round/>
+                      <a:headEnd type="none" w="med" len="med"/>
+                      <a:tailEnd type="none" w="med" len="med"/>
+                    </a:lnL>
+                    <a:lnR w="12700" cap="flat" cmpd="sng" algn="ctr">
+                      <a:solidFill>
+                        <a:srgbClr val="000000"/>
+                      </a:solidFill>
+                      <a:prstDash val="solid"/>
+                      <a:round/>
+                      <a:headEnd type="none" w="med" len="med"/>
+                      <a:tailEnd type="none" w="med" len="med"/>
+                    </a:lnR>
+                    <a:lnT w="12700" cap="flat" cmpd="sng" algn="ctr">
+                      <a:solidFill>
+                        <a:srgbClr val="000000"/>
+                      </a:solidFill>
+                      <a:prstDash val="solid"/>
+                      <a:round/>
+                      <a:headEnd type="none" w="med" len="med"/>
+                      <a:tailEnd type="none" w="med" len="med"/>
+                    </a:lnT>
+                    <a:lnB w="12700" cap="flat" cmpd="sng" algn="ctr">
+                      <a:solidFill>
+                        <a:srgbClr val="000000"/>
+                      </a:solidFill>
+                      <a:prstDash val="solid"/>
+                      <a:round/>
+                      <a:headEnd type="none" w="med" len="med"/>
+                      <a:tailEnd type="none" w="med" len="med"/>
+                    </a:lnB>
+                    <a:noFill/>
+                  </a:tcPr>
+                </a:tc>
+                <a:tc>
+                  <a:txBody>
+                    <a:bodyPr/>
+                    <a:lstStyle/>
+                    <a:p>
+                      <a:pPr>
+                        <a:buNone/>
+                      </a:pPr>
+                      <a:r>
+                        <a:rPr lang="en-US" sz="1000">
+                          <a:effectLst/>
+                          <a:latin typeface="Times New Roman" panose="02020603050405020304" pitchFamily="18" charset="0"/>
+                          <a:ea typeface="游明朝" panose="02020400000000000000" pitchFamily="18" charset="-128"/>
+                        </a:rPr>
+                        <a:t>150</a:t>
+                      </a:r>
+                      <a:endParaRPr lang="ja-JP" sz="1000">
+                        <a:effectLst/>
+                        <a:latin typeface="Times New Roman" panose="02020603050405020304" pitchFamily="18" charset="0"/>
+                        <a:ea typeface="游明朝" panose="02020400000000000000" pitchFamily="18" charset="-128"/>
+                      </a:endParaRPr>
+                    </a:p>
+                    <a:p>
+                      <a:pPr>
+                        <a:buNone/>
+                      </a:pPr>
+                      <a:endParaRPr lang="ja-JP" sz="1000">
+                        <a:effectLst/>
+                        <a:latin typeface="Times New Roman" panose="02020603050405020304" pitchFamily="18" charset="0"/>
+                      </a:endParaRPr>
+                    </a:p>
+                  </a:txBody>
+                  <a:tcPr marL="6350" marR="6350" marT="0" marB="0">
+                    <a:lnL w="12700" cap="flat" cmpd="sng" algn="ctr">
+                      <a:solidFill>
+                        <a:srgbClr val="000000"/>
+                      </a:solidFill>
+                      <a:prstDash val="solid"/>
+                      <a:round/>
+                      <a:headEnd type="none" w="med" len="med"/>
+                      <a:tailEnd type="none" w="med" len="med"/>
+                    </a:lnL>
+                    <a:lnR w="12700" cap="flat" cmpd="sng" algn="ctr">
+                      <a:solidFill>
+                        <a:srgbClr val="000000"/>
+                      </a:solidFill>
+                      <a:prstDash val="solid"/>
+                      <a:round/>
+                      <a:headEnd type="none" w="med" len="med"/>
+                      <a:tailEnd type="none" w="med" len="med"/>
+                    </a:lnR>
+                    <a:lnT w="12700" cap="flat" cmpd="sng" algn="ctr">
+                      <a:solidFill>
+                        <a:srgbClr val="000000"/>
+                      </a:solidFill>
+                      <a:prstDash val="solid"/>
+                      <a:round/>
+                      <a:headEnd type="none" w="med" len="med"/>
+                      <a:tailEnd type="none" w="med" len="med"/>
+                    </a:lnT>
+                    <a:lnB w="12700" cap="flat" cmpd="sng" algn="ctr">
+                      <a:solidFill>
+                        <a:srgbClr val="000000"/>
+                      </a:solidFill>
+                      <a:prstDash val="solid"/>
+                      <a:round/>
+                      <a:headEnd type="none" w="med" len="med"/>
+                      <a:tailEnd type="none" w="med" len="med"/>
+                    </a:lnB>
+                    <a:noFill/>
+                  </a:tcPr>
+                </a:tc>
+                <a:tc>
+                  <a:txBody>
+                    <a:bodyPr/>
+                    <a:lstStyle/>
+                    <a:p>
+                      <a:pPr>
+                        <a:buNone/>
+                      </a:pPr>
+                      <a:r>
+                        <a:rPr lang="en-US" sz="1000">
+                          <a:effectLst/>
+                          <a:latin typeface="Times New Roman" panose="02020603050405020304" pitchFamily="18" charset="0"/>
+                          <a:ea typeface="游明朝" panose="02020400000000000000" pitchFamily="18" charset="-128"/>
+                        </a:rPr>
+                        <a:t>450</a:t>
+                      </a:r>
+                      <a:endParaRPr lang="ja-JP" sz="1000">
+                        <a:effectLst/>
+                        <a:latin typeface="Times New Roman" panose="02020603050405020304" pitchFamily="18" charset="0"/>
+                        <a:ea typeface="游明朝" panose="02020400000000000000" pitchFamily="18" charset="-128"/>
+                      </a:endParaRPr>
+                    </a:p>
+                    <a:p>
+                      <a:pPr>
+                        <a:buNone/>
+                      </a:pPr>
+                      <a:endParaRPr lang="ja-JP" sz="1000">
+                        <a:effectLst/>
+                        <a:latin typeface="Times New Roman" panose="02020603050405020304" pitchFamily="18" charset="0"/>
+                      </a:endParaRPr>
+                    </a:p>
+                  </a:txBody>
+                  <a:tcPr marL="6350" marR="6350" marT="0" marB="0">
+                    <a:lnL w="12700" cap="flat" cmpd="sng" algn="ctr">
+                      <a:solidFill>
+                        <a:srgbClr val="000000"/>
+                      </a:solidFill>
+                      <a:prstDash val="solid"/>
+                      <a:round/>
+                      <a:headEnd type="none" w="med" len="med"/>
+                      <a:tailEnd type="none" w="med" len="med"/>
+                    </a:lnL>
+                    <a:lnR w="12700" cap="flat" cmpd="sng" algn="ctr">
+                      <a:solidFill>
+                        <a:srgbClr val="000000"/>
+                      </a:solidFill>
+                      <a:prstDash val="solid"/>
+                      <a:round/>
+                      <a:headEnd type="none" w="med" len="med"/>
+                      <a:tailEnd type="none" w="med" len="med"/>
+                    </a:lnR>
+                    <a:lnT w="12700" cap="flat" cmpd="sng" algn="ctr">
+                      <a:solidFill>
+                        <a:srgbClr val="000000"/>
+                      </a:solidFill>
+                      <a:prstDash val="solid"/>
+                      <a:round/>
+                      <a:headEnd type="none" w="med" len="med"/>
+                      <a:tailEnd type="none" w="med" len="med"/>
+                    </a:lnT>
+                    <a:lnB w="12700" cap="flat" cmpd="sng" algn="ctr">
+                      <a:solidFill>
+                        <a:srgbClr val="000000"/>
+                      </a:solidFill>
+                      <a:prstDash val="solid"/>
+                      <a:round/>
+                      <a:headEnd type="none" w="med" len="med"/>
+                      <a:tailEnd type="none" w="med" len="med"/>
+                    </a:lnB>
+                    <a:noFill/>
+                  </a:tcPr>
+                </a:tc>
+                <a:extLst>
+                  <a:ext uri="{0D108BD9-81ED-4DB2-BD59-A6C34878D82A}">
+                    <a16:rowId xmlns:a16="http://schemas.microsoft.com/office/drawing/2014/main" val="3502669527"/>
+                  </a:ext>
+                </a:extLst>
+              </a:tr>
+              <a:tr h="0">
+                <a:tc>
+                  <a:txBody>
+                    <a:bodyPr/>
+                    <a:lstStyle/>
+                    <a:p>
+                      <a:pPr>
+                        <a:buNone/>
+                      </a:pPr>
+                      <a:r>
+                        <a:rPr lang="ja-JP" sz="1000">
+                          <a:effectLst/>
+                          <a:latin typeface="Times New Roman" panose="02020603050405020304" pitchFamily="18" charset="0"/>
+                          <a:ea typeface="游明朝" panose="02020400000000000000" pitchFamily="18" charset="-128"/>
+                        </a:rPr>
+                        <a:t>バナナ</a:t>
+                      </a:r>
+                    </a:p>
+                    <a:p>
+                      <a:pPr>
+                        <a:buNone/>
+                      </a:pPr>
+                      <a:endParaRPr lang="ja-JP" sz="1000">
+                        <a:effectLst/>
+                        <a:latin typeface="Times New Roman" panose="02020603050405020304" pitchFamily="18" charset="0"/>
+                      </a:endParaRPr>
+                    </a:p>
+                  </a:txBody>
+                  <a:tcPr marL="6350" marR="6350" marT="0" marB="0">
+                    <a:lnL w="12700" cap="flat" cmpd="sng" algn="ctr">
+                      <a:solidFill>
+                        <a:srgbClr val="000000"/>
+                      </a:solidFill>
+                      <a:prstDash val="solid"/>
+                      <a:round/>
+                      <a:headEnd type="none" w="med" len="med"/>
+                      <a:tailEnd type="none" w="med" len="med"/>
+                    </a:lnL>
+                    <a:lnR w="12700" cap="flat" cmpd="sng" algn="ctr">
+                      <a:solidFill>
+                        <a:srgbClr val="000000"/>
+                      </a:solidFill>
+                      <a:prstDash val="solid"/>
+                      <a:round/>
+                      <a:headEnd type="none" w="med" len="med"/>
+                      <a:tailEnd type="none" w="med" len="med"/>
+                    </a:lnR>
+                    <a:lnT w="12700" cap="flat" cmpd="sng" algn="ctr">
+                      <a:solidFill>
+                        <a:srgbClr val="000000"/>
+                      </a:solidFill>
+                      <a:prstDash val="solid"/>
+                      <a:round/>
+                      <a:headEnd type="none" w="med" len="med"/>
+                      <a:tailEnd type="none" w="med" len="med"/>
+                    </a:lnT>
+                    <a:lnB w="12700" cap="flat" cmpd="sng" algn="ctr">
+                      <a:solidFill>
+                        <a:srgbClr val="000000"/>
+                      </a:solidFill>
+                      <a:prstDash val="solid"/>
+                      <a:round/>
+                      <a:headEnd type="none" w="med" len="med"/>
+                      <a:tailEnd type="none" w="med" len="med"/>
+                    </a:lnB>
+                    <a:noFill/>
+                  </a:tcPr>
+                </a:tc>
+                <a:tc>
+                  <a:txBody>
+                    <a:bodyPr/>
+                    <a:lstStyle/>
+                    <a:p>
+                      <a:pPr>
+                        <a:buNone/>
+                      </a:pPr>
+                      <a:r>
+                        <a:rPr lang="en-US" sz="1000">
+                          <a:effectLst/>
+                          <a:latin typeface="Times New Roman" panose="02020603050405020304" pitchFamily="18" charset="0"/>
+                          <a:ea typeface="游明朝" panose="02020400000000000000" pitchFamily="18" charset="-128"/>
+                        </a:rPr>
+                        <a:t>5</a:t>
+                      </a:r>
+                      <a:endParaRPr lang="ja-JP" sz="1000">
+                        <a:effectLst/>
+                        <a:latin typeface="Times New Roman" panose="02020603050405020304" pitchFamily="18" charset="0"/>
+                        <a:ea typeface="游明朝" panose="02020400000000000000" pitchFamily="18" charset="-128"/>
+                      </a:endParaRPr>
+                    </a:p>
+                    <a:p>
+                      <a:pPr>
+                        <a:buNone/>
+                      </a:pPr>
+                      <a:endParaRPr lang="ja-JP" sz="1000">
+                        <a:effectLst/>
+                        <a:latin typeface="Times New Roman" panose="02020603050405020304" pitchFamily="18" charset="0"/>
+                      </a:endParaRPr>
+                    </a:p>
+                  </a:txBody>
+                  <a:tcPr marL="6350" marR="6350" marT="0" marB="0">
+                    <a:lnL w="12700" cap="flat" cmpd="sng" algn="ctr">
+                      <a:solidFill>
+                        <a:srgbClr val="000000"/>
+                      </a:solidFill>
+                      <a:prstDash val="solid"/>
+                      <a:round/>
+                      <a:headEnd type="none" w="med" len="med"/>
+                      <a:tailEnd type="none" w="med" len="med"/>
+                    </a:lnL>
+                    <a:lnR w="12700" cap="flat" cmpd="sng" algn="ctr">
+                      <a:solidFill>
+                        <a:srgbClr val="000000"/>
+                      </a:solidFill>
+                      <a:prstDash val="solid"/>
+                      <a:round/>
+                      <a:headEnd type="none" w="med" len="med"/>
+                      <a:tailEnd type="none" w="med" len="med"/>
+                    </a:lnR>
+                    <a:lnT w="12700" cap="flat" cmpd="sng" algn="ctr">
+                      <a:solidFill>
+                        <a:srgbClr val="000000"/>
+                      </a:solidFill>
+                      <a:prstDash val="solid"/>
+                      <a:round/>
+                      <a:headEnd type="none" w="med" len="med"/>
+                      <a:tailEnd type="none" w="med" len="med"/>
+                    </a:lnT>
+                    <a:lnB w="12700" cap="flat" cmpd="sng" algn="ctr">
+                      <a:solidFill>
+                        <a:srgbClr val="000000"/>
+                      </a:solidFill>
+                      <a:prstDash val="solid"/>
+                      <a:round/>
+                      <a:headEnd type="none" w="med" len="med"/>
+                      <a:tailEnd type="none" w="med" len="med"/>
+                    </a:lnB>
+                    <a:noFill/>
+                  </a:tcPr>
+                </a:tc>
+                <a:tc>
+                  <a:txBody>
+                    <a:bodyPr/>
+                    <a:lstStyle/>
+                    <a:p>
+                      <a:pPr>
+                        <a:buNone/>
+                      </a:pPr>
+                      <a:r>
+                        <a:rPr lang="en-US" sz="1000">
+                          <a:effectLst/>
+                          <a:latin typeface="Times New Roman" panose="02020603050405020304" pitchFamily="18" charset="0"/>
+                          <a:ea typeface="游明朝" panose="02020400000000000000" pitchFamily="18" charset="-128"/>
+                        </a:rPr>
+                        <a:t>100</a:t>
+                      </a:r>
+                      <a:endParaRPr lang="ja-JP" sz="1000">
+                        <a:effectLst/>
+                        <a:latin typeface="Times New Roman" panose="02020603050405020304" pitchFamily="18" charset="0"/>
+                        <a:ea typeface="游明朝" panose="02020400000000000000" pitchFamily="18" charset="-128"/>
+                      </a:endParaRPr>
+                    </a:p>
+                    <a:p>
+                      <a:pPr>
+                        <a:buNone/>
+                      </a:pPr>
+                      <a:endParaRPr lang="ja-JP" sz="1000">
+                        <a:effectLst/>
+                        <a:latin typeface="Times New Roman" panose="02020603050405020304" pitchFamily="18" charset="0"/>
+                      </a:endParaRPr>
+                    </a:p>
+                  </a:txBody>
+                  <a:tcPr marL="6350" marR="6350" marT="0" marB="0">
+                    <a:lnL w="12700" cap="flat" cmpd="sng" algn="ctr">
+                      <a:solidFill>
+                        <a:srgbClr val="000000"/>
+                      </a:solidFill>
+                      <a:prstDash val="solid"/>
+                      <a:round/>
+                      <a:headEnd type="none" w="med" len="med"/>
+                      <a:tailEnd type="none" w="med" len="med"/>
+                    </a:lnL>
+                    <a:lnR w="12700" cap="flat" cmpd="sng" algn="ctr">
+                      <a:solidFill>
+                        <a:srgbClr val="000000"/>
+                      </a:solidFill>
+                      <a:prstDash val="solid"/>
+                      <a:round/>
+                      <a:headEnd type="none" w="med" len="med"/>
+                      <a:tailEnd type="none" w="med" len="med"/>
+                    </a:lnR>
+                    <a:lnT w="12700" cap="flat" cmpd="sng" algn="ctr">
+                      <a:solidFill>
+                        <a:srgbClr val="000000"/>
+                      </a:solidFill>
+                      <a:prstDash val="solid"/>
+                      <a:round/>
+                      <a:headEnd type="none" w="med" len="med"/>
+                      <a:tailEnd type="none" w="med" len="med"/>
+                    </a:lnT>
+                    <a:lnB w="12700" cap="flat" cmpd="sng" algn="ctr">
+                      <a:solidFill>
+                        <a:srgbClr val="000000"/>
+                      </a:solidFill>
+                      <a:prstDash val="solid"/>
+                      <a:round/>
+                      <a:headEnd type="none" w="med" len="med"/>
+                      <a:tailEnd type="none" w="med" len="med"/>
+                    </a:lnB>
+                    <a:noFill/>
+                  </a:tcPr>
+                </a:tc>
+                <a:tc>
+                  <a:txBody>
+                    <a:bodyPr/>
+                    <a:lstStyle/>
+                    <a:p>
+                      <a:pPr>
+                        <a:buNone/>
+                      </a:pPr>
+                      <a:r>
+                        <a:rPr lang="en-US" sz="1000">
+                          <a:effectLst/>
+                          <a:latin typeface="Times New Roman" panose="02020603050405020304" pitchFamily="18" charset="0"/>
+                          <a:ea typeface="游明朝" panose="02020400000000000000" pitchFamily="18" charset="-128"/>
+                        </a:rPr>
+                        <a:t>500</a:t>
+                      </a:r>
+                      <a:endParaRPr lang="ja-JP" sz="1000">
+                        <a:effectLst/>
+                        <a:latin typeface="Times New Roman" panose="02020603050405020304" pitchFamily="18" charset="0"/>
+                        <a:ea typeface="游明朝" panose="02020400000000000000" pitchFamily="18" charset="-128"/>
+                      </a:endParaRPr>
+                    </a:p>
+                    <a:p>
+                      <a:pPr>
+                        <a:buNone/>
+                      </a:pPr>
+                      <a:endParaRPr lang="ja-JP" sz="1000">
+                        <a:effectLst/>
+                        <a:latin typeface="Times New Roman" panose="02020603050405020304" pitchFamily="18" charset="0"/>
+                      </a:endParaRPr>
+                    </a:p>
+                  </a:txBody>
+                  <a:tcPr marL="6350" marR="6350" marT="0" marB="0">
+                    <a:lnL w="12700" cap="flat" cmpd="sng" algn="ctr">
+                      <a:solidFill>
+                        <a:srgbClr val="000000"/>
+                      </a:solidFill>
+                      <a:prstDash val="solid"/>
+                      <a:round/>
+                      <a:headEnd type="none" w="med" len="med"/>
+                      <a:tailEnd type="none" w="med" len="med"/>
+                    </a:lnL>
+                    <a:lnR w="12700" cap="flat" cmpd="sng" algn="ctr">
+                      <a:solidFill>
+                        <a:srgbClr val="000000"/>
+                      </a:solidFill>
+                      <a:prstDash val="solid"/>
+                      <a:round/>
+                      <a:headEnd type="none" w="med" len="med"/>
+                      <a:tailEnd type="none" w="med" len="med"/>
+                    </a:lnR>
+                    <a:lnT w="12700" cap="flat" cmpd="sng" algn="ctr">
+                      <a:solidFill>
+                        <a:srgbClr val="000000"/>
+                      </a:solidFill>
+                      <a:prstDash val="solid"/>
+                      <a:round/>
+                      <a:headEnd type="none" w="med" len="med"/>
+                      <a:tailEnd type="none" w="med" len="med"/>
+                    </a:lnT>
+                    <a:lnB w="12700" cap="flat" cmpd="sng" algn="ctr">
+                      <a:solidFill>
+                        <a:srgbClr val="000000"/>
+                      </a:solidFill>
+                      <a:prstDash val="solid"/>
+                      <a:round/>
+                      <a:headEnd type="none" w="med" len="med"/>
+                      <a:tailEnd type="none" w="med" len="med"/>
+                    </a:lnB>
+                    <a:noFill/>
+                  </a:tcPr>
+                </a:tc>
+                <a:extLst>
+                  <a:ext uri="{0D108BD9-81ED-4DB2-BD59-A6C34878D82A}">
+                    <a16:rowId xmlns:a16="http://schemas.microsoft.com/office/drawing/2014/main" val="2873402986"/>
+                  </a:ext>
+                </a:extLst>
+              </a:tr>
+              <a:tr h="0">
+                <a:tc>
+                  <a:txBody>
+                    <a:bodyPr/>
+                    <a:lstStyle/>
+                    <a:p>
+                      <a:pPr>
+                        <a:buNone/>
+                      </a:pPr>
+                      <a:r>
+                        <a:rPr lang="ja-JP" sz="1000">
+                          <a:effectLst/>
+                          <a:latin typeface="Times New Roman" panose="02020603050405020304" pitchFamily="18" charset="0"/>
+                          <a:ea typeface="游明朝" panose="02020400000000000000" pitchFamily="18" charset="-128"/>
+                        </a:rPr>
+                        <a:t>みかん</a:t>
+                      </a:r>
+                    </a:p>
+                    <a:p>
+                      <a:pPr>
+                        <a:buNone/>
+                      </a:pPr>
+                      <a:endParaRPr lang="ja-JP" sz="1000">
+                        <a:effectLst/>
+                        <a:latin typeface="Times New Roman" panose="02020603050405020304" pitchFamily="18" charset="0"/>
+                      </a:endParaRPr>
+                    </a:p>
+                  </a:txBody>
+                  <a:tcPr marL="6350" marR="6350" marT="0" marB="0">
+                    <a:lnL w="12700" cap="flat" cmpd="sng" algn="ctr">
+                      <a:solidFill>
+                        <a:srgbClr val="000000"/>
+                      </a:solidFill>
+                      <a:prstDash val="solid"/>
+                      <a:round/>
+                      <a:headEnd type="none" w="med" len="med"/>
+                      <a:tailEnd type="none" w="med" len="med"/>
+                    </a:lnL>
+                    <a:lnR w="12700" cap="flat" cmpd="sng" algn="ctr">
+                      <a:solidFill>
+                        <a:srgbClr val="000000"/>
+                      </a:solidFill>
+                      <a:prstDash val="solid"/>
+                      <a:round/>
+                      <a:headEnd type="none" w="med" len="med"/>
+                      <a:tailEnd type="none" w="med" len="med"/>
+                    </a:lnR>
+                    <a:lnT w="12700" cap="flat" cmpd="sng" algn="ctr">
+                      <a:solidFill>
+                        <a:srgbClr val="000000"/>
+                      </a:solidFill>
+                      <a:prstDash val="solid"/>
+                      <a:round/>
+                      <a:headEnd type="none" w="med" len="med"/>
+                      <a:tailEnd type="none" w="med" len="med"/>
+                    </a:lnT>
+                    <a:lnB w="12700" cap="flat" cmpd="sng" algn="ctr">
+                      <a:solidFill>
+                        <a:srgbClr val="000000"/>
+                      </a:solidFill>
+                      <a:prstDash val="solid"/>
+                      <a:round/>
+                      <a:headEnd type="none" w="med" len="med"/>
+                      <a:tailEnd type="none" w="med" len="med"/>
+                    </a:lnB>
+                    <a:noFill/>
+                  </a:tcPr>
+                </a:tc>
+                <a:tc>
+                  <a:txBody>
+                    <a:bodyPr/>
+                    <a:lstStyle/>
+                    <a:p>
+                      <a:pPr>
+                        <a:buNone/>
+                      </a:pPr>
+                      <a:r>
+                        <a:rPr lang="en-US" sz="1000" dirty="0">
+                          <a:effectLst/>
+                          <a:latin typeface="Times New Roman" panose="02020603050405020304" pitchFamily="18" charset="0"/>
+                          <a:ea typeface="游明朝" panose="02020400000000000000" pitchFamily="18" charset="-128"/>
+                        </a:rPr>
+                        <a:t>8</a:t>
+                      </a:r>
+                      <a:endParaRPr lang="ja-JP" sz="1000" dirty="0">
+                        <a:effectLst/>
+                        <a:latin typeface="Times New Roman" panose="02020603050405020304" pitchFamily="18" charset="0"/>
+                        <a:ea typeface="游明朝" panose="02020400000000000000" pitchFamily="18" charset="-128"/>
+                      </a:endParaRPr>
+                    </a:p>
+                    <a:p>
+                      <a:pPr>
+                        <a:buNone/>
+                      </a:pPr>
+                      <a:endParaRPr lang="ja-JP" sz="1000" dirty="0">
+                        <a:effectLst/>
+                        <a:latin typeface="Times New Roman" panose="02020603050405020304" pitchFamily="18" charset="0"/>
+                      </a:endParaRPr>
+                    </a:p>
+                  </a:txBody>
+                  <a:tcPr marL="6350" marR="6350" marT="0" marB="0">
+                    <a:lnL w="12700" cap="flat" cmpd="sng" algn="ctr">
+                      <a:solidFill>
+                        <a:srgbClr val="000000"/>
+                      </a:solidFill>
+                      <a:prstDash val="solid"/>
+                      <a:round/>
+                      <a:headEnd type="none" w="med" len="med"/>
+                      <a:tailEnd type="none" w="med" len="med"/>
+                    </a:lnL>
+                    <a:lnR w="12700" cap="flat" cmpd="sng" algn="ctr">
+                      <a:solidFill>
+                        <a:srgbClr val="000000"/>
+                      </a:solidFill>
+                      <a:prstDash val="solid"/>
+                      <a:round/>
+                      <a:headEnd type="none" w="med" len="med"/>
+                      <a:tailEnd type="none" w="med" len="med"/>
+                    </a:lnR>
+                    <a:lnT w="12700" cap="flat" cmpd="sng" algn="ctr">
+                      <a:solidFill>
+                        <a:srgbClr val="000000"/>
+                      </a:solidFill>
+                      <a:prstDash val="solid"/>
+                      <a:round/>
+                      <a:headEnd type="none" w="med" len="med"/>
+                      <a:tailEnd type="none" w="med" len="med"/>
+                    </a:lnT>
+                    <a:lnB w="12700" cap="flat" cmpd="sng" algn="ctr">
+                      <a:solidFill>
+                        <a:srgbClr val="000000"/>
+                      </a:solidFill>
+                      <a:prstDash val="solid"/>
+                      <a:round/>
+                      <a:headEnd type="none" w="med" len="med"/>
+                      <a:tailEnd type="none" w="med" len="med"/>
+                    </a:lnB>
+                    <a:noFill/>
+                  </a:tcPr>
+                </a:tc>
+                <a:tc>
+                  <a:txBody>
+                    <a:bodyPr/>
+                    <a:lstStyle/>
+                    <a:p>
+                      <a:pPr>
+                        <a:buNone/>
+                      </a:pPr>
+                      <a:r>
+                        <a:rPr lang="en-US" sz="1000">
+                          <a:effectLst/>
+                          <a:latin typeface="Times New Roman" panose="02020603050405020304" pitchFamily="18" charset="0"/>
+                          <a:ea typeface="游明朝" panose="02020400000000000000" pitchFamily="18" charset="-128"/>
+                        </a:rPr>
+                        <a:t>80</a:t>
+                      </a:r>
+                      <a:endParaRPr lang="ja-JP" sz="1000">
+                        <a:effectLst/>
+                        <a:latin typeface="Times New Roman" panose="02020603050405020304" pitchFamily="18" charset="0"/>
+                        <a:ea typeface="游明朝" panose="02020400000000000000" pitchFamily="18" charset="-128"/>
+                      </a:endParaRPr>
+                    </a:p>
+                    <a:p>
+                      <a:pPr>
+                        <a:buNone/>
+                      </a:pPr>
+                      <a:endParaRPr lang="ja-JP" sz="1000">
+                        <a:effectLst/>
+                        <a:latin typeface="Times New Roman" panose="02020603050405020304" pitchFamily="18" charset="0"/>
+                      </a:endParaRPr>
+                    </a:p>
+                  </a:txBody>
+                  <a:tcPr marL="6350" marR="6350" marT="0" marB="0">
+                    <a:lnL w="12700" cap="flat" cmpd="sng" algn="ctr">
+                      <a:solidFill>
+                        <a:srgbClr val="000000"/>
+                      </a:solidFill>
+                      <a:prstDash val="solid"/>
+                      <a:round/>
+                      <a:headEnd type="none" w="med" len="med"/>
+                      <a:tailEnd type="none" w="med" len="med"/>
+                    </a:lnL>
+                    <a:lnR w="12700" cap="flat" cmpd="sng" algn="ctr">
+                      <a:solidFill>
+                        <a:srgbClr val="000000"/>
+                      </a:solidFill>
+                      <a:prstDash val="solid"/>
+                      <a:round/>
+                      <a:headEnd type="none" w="med" len="med"/>
+                      <a:tailEnd type="none" w="med" len="med"/>
+                    </a:lnR>
+                    <a:lnT w="12700" cap="flat" cmpd="sng" algn="ctr">
+                      <a:solidFill>
+                        <a:srgbClr val="000000"/>
+                      </a:solidFill>
+                      <a:prstDash val="solid"/>
+                      <a:round/>
+                      <a:headEnd type="none" w="med" len="med"/>
+                      <a:tailEnd type="none" w="med" len="med"/>
+                    </a:lnT>
+                    <a:lnB w="12700" cap="flat" cmpd="sng" algn="ctr">
+                      <a:solidFill>
+                        <a:srgbClr val="000000"/>
+                      </a:solidFill>
+                      <a:prstDash val="solid"/>
+                      <a:round/>
+                      <a:headEnd type="none" w="med" len="med"/>
+                      <a:tailEnd type="none" w="med" len="med"/>
+                    </a:lnB>
+                    <a:noFill/>
+                  </a:tcPr>
+                </a:tc>
+                <a:tc>
+                  <a:txBody>
+                    <a:bodyPr/>
+                    <a:lstStyle/>
+                    <a:p>
+                      <a:pPr>
+                        <a:buNone/>
+                      </a:pPr>
+                      <a:r>
+                        <a:rPr lang="en-US" sz="1000" dirty="0">
+                          <a:effectLst/>
+                          <a:latin typeface="Times New Roman" panose="02020603050405020304" pitchFamily="18" charset="0"/>
+                          <a:ea typeface="游明朝" panose="02020400000000000000" pitchFamily="18" charset="-128"/>
+                        </a:rPr>
+                        <a:t>640</a:t>
+                      </a:r>
+                      <a:endParaRPr lang="ja-JP" sz="1000" dirty="0">
+                        <a:effectLst/>
+                        <a:latin typeface="Times New Roman" panose="02020603050405020304" pitchFamily="18" charset="0"/>
+                        <a:ea typeface="游明朝" panose="02020400000000000000" pitchFamily="18" charset="-128"/>
+                      </a:endParaRPr>
+                    </a:p>
+                    <a:p>
+                      <a:pPr>
+                        <a:buNone/>
+                      </a:pPr>
+                      <a:endParaRPr lang="ja-JP" sz="1000" dirty="0">
+                        <a:effectLst/>
+                        <a:latin typeface="Times New Roman" panose="02020603050405020304" pitchFamily="18" charset="0"/>
+                      </a:endParaRPr>
+                    </a:p>
+                  </a:txBody>
+                  <a:tcPr marL="6350" marR="6350" marT="0" marB="0">
+                    <a:lnL w="12700" cap="flat" cmpd="sng" algn="ctr">
+                      <a:solidFill>
+                        <a:srgbClr val="000000"/>
+                      </a:solidFill>
+                      <a:prstDash val="solid"/>
+                      <a:round/>
+                      <a:headEnd type="none" w="med" len="med"/>
+                      <a:tailEnd type="none" w="med" len="med"/>
+                    </a:lnL>
+                    <a:lnR w="12700" cap="flat" cmpd="sng" algn="ctr">
+                      <a:solidFill>
+                        <a:srgbClr val="000000"/>
+                      </a:solidFill>
+                      <a:prstDash val="solid"/>
+                      <a:round/>
+                      <a:headEnd type="none" w="med" len="med"/>
+                      <a:tailEnd type="none" w="med" len="med"/>
+                    </a:lnR>
+                    <a:lnT w="12700" cap="flat" cmpd="sng" algn="ctr">
+                      <a:solidFill>
+                        <a:srgbClr val="000000"/>
+                      </a:solidFill>
+                      <a:prstDash val="solid"/>
+                      <a:round/>
+                      <a:headEnd type="none" w="med" len="med"/>
+                      <a:tailEnd type="none" w="med" len="med"/>
+                    </a:lnT>
+                    <a:lnB w="12700" cap="flat" cmpd="sng" algn="ctr">
+                      <a:solidFill>
+                        <a:srgbClr val="000000"/>
+                      </a:solidFill>
+                      <a:prstDash val="solid"/>
+                      <a:round/>
+                      <a:headEnd type="none" w="med" len="med"/>
+                      <a:tailEnd type="none" w="med" len="med"/>
+                    </a:lnB>
+                    <a:noFill/>
+                  </a:tcPr>
+                </a:tc>
+                <a:extLst>
+                  <a:ext uri="{0D108BD9-81ED-4DB2-BD59-A6C34878D82A}">
+                    <a16:rowId xmlns:a16="http://schemas.microsoft.com/office/drawing/2014/main" val="3917828429"/>
+                  </a:ext>
+                </a:extLst>
+              </a:tr>
+            </a:tbl>
+          </a:graphicData>
+        </a:graphic>
+      </p:graphicFrame>
+      <p:sp>
+        <p:nvSpPr>
+          <p:cNvPr id="8" name="Text 0">
+            <a:extLst>
+              <a:ext uri="{FF2B5EF4-FFF2-40B4-BE49-F238E27FC236}">
+                <a16:creationId xmlns:a16="http://schemas.microsoft.com/office/drawing/2014/main" id="{2A02BA68-03FC-92A1-4D02-F5AA092A9F8C}"/>
+              </a:ext>
+            </a:extLst>
+          </p:cNvPr>
+          <p:cNvSpPr/>
+          <p:nvPr/>
+        </p:nvSpPr>
+        <p:spPr>
+          <a:xfrm>
+            <a:off x="380010" y="326571"/>
+            <a:ext cx="8229600" cy="914400"/>
+          </a:xfrm>
+          <a:prstGeom prst="rect">
+            <a:avLst/>
+          </a:prstGeom>
+          <a:noFill/>
+          <a:ln/>
+        </p:spPr>
+        <p:txBody>
+          <a:bodyPr wrap="square" rtlCol="0" anchor="ctr"/>
+          <a:lstStyle/>
+          <a:p>
+            <a:pPr marL="0" indent="0">
+              <a:buNone/>
+            </a:pPr>
+            <a:r>
+              <a:rPr lang="ja-JP" altLang="en-US" sz="3600" b="1" dirty="0">
+                <a:solidFill>
+                  <a:srgbClr val="000000"/>
+                </a:solidFill>
+              </a:rPr>
+              <a:t>表と図がある</a:t>
+            </a:r>
+            <a:endParaRPr lang="en-US" sz="3600" dirty="0"/>
+          </a:p>
+        </p:txBody>
+      </p:sp>
+      <p:sp>
+        <p:nvSpPr>
+          <p:cNvPr id="9" name="Rectangle 2">
+            <a:extLst>
+              <a:ext uri="{FF2B5EF4-FFF2-40B4-BE49-F238E27FC236}">
+                <a16:creationId xmlns:a16="http://schemas.microsoft.com/office/drawing/2014/main" id="{FBA3632C-4499-F8B1-03EF-43C736D8A2AA}"/>
+              </a:ext>
+            </a:extLst>
+          </p:cNvPr>
+          <p:cNvSpPr>
+            <a:spLocks noChangeArrowheads="1"/>
+          </p:cNvSpPr>
+          <p:nvPr/>
+        </p:nvSpPr>
+        <p:spPr bwMode="auto">
+          <a:xfrm>
+            <a:off x="6508773" y="-168508"/>
+            <a:ext cx="2100837" cy="143317"/>
+          </a:xfrm>
+          <a:prstGeom prst="rect">
+            <a:avLst/>
+          </a:prstGeom>
+          <a:noFill/>
+          <a:ln>
+            <a:noFill/>
+          </a:ln>
+          <a:effectLst/>
+          <a:extLst>
+            <a:ext uri="{909E8E84-426E-40DD-AFC4-6F175D3DCCD1}">
+              <a14:hiddenFill xmlns:a14="http://schemas.microsoft.com/office/drawing/2010/main">
+                <a:solidFill>
+                  <a:schemeClr val="accent1"/>
+                </a:solidFill>
+              </a14:hiddenFill>
+            </a:ext>
+            <a:ext uri="{91240B29-F687-4F45-9708-019B960494DF}">
+              <a14:hiddenLine xmlns:a14="http://schemas.microsoft.com/office/drawing/2010/main" w="9525">
+                <a:solidFill>
+                  <a:schemeClr val="tx1"/>
+                </a:solidFill>
+                <a:miter lim="800000"/>
+                <a:headEnd/>
+                <a:tailEnd/>
+              </a14:hiddenLine>
+            </a:ext>
+            <a:ext uri="{AF507438-7753-43E0-B8FC-AC1667EBCBE1}">
+              <a14:hiddenEffects xmlns:a14="http://schemas.microsoft.com/office/drawing/2010/main">
+                <a:effectLst>
+                  <a:outerShdw dist="35921" dir="2700000" algn="ctr" rotWithShape="0">
+                    <a:schemeClr val="bg2"/>
+                  </a:outerShdw>
+                </a:effectLst>
+              </a14:hiddenEffects>
+            </a:ext>
+          </a:extLst>
+        </p:spPr>
+        <p:txBody>
+          <a:bodyPr vert="horz" wrap="square" lIns="91440" tIns="45720" rIns="91440" bIns="45720" numCol="1" anchor="ctr" anchorCtr="0" compatLnSpc="1">
+            <a:prstTxWarp prst="textNoShape">
+              <a:avLst/>
+            </a:prstTxWarp>
+            <a:spAutoFit/>
+          </a:bodyPr>
+          <a:lstStyle/>
+          <a:p>
+            <a:endParaRPr lang="ja-JP" altLang="en-US"/>
+          </a:p>
+        </p:txBody>
+      </p:sp>
+      <p:pic>
+        <p:nvPicPr>
+          <p:cNvPr id="2049" name="図 1">
+            <a:extLst>
+              <a:ext uri="{FF2B5EF4-FFF2-40B4-BE49-F238E27FC236}">
+                <a16:creationId xmlns:a16="http://schemas.microsoft.com/office/drawing/2014/main" id="{66F9606B-AB0E-0F0C-6B22-8808DB2E425A}"/>
+              </a:ext>
+            </a:extLst>
+          </p:cNvPr>
+          <p:cNvPicPr>
+            <a:picLocks noChangeAspect="1" noChangeArrowheads="1"/>
+          </p:cNvPicPr>
+          <p:nvPr/>
+        </p:nvPicPr>
+        <p:blipFill>
+          <a:blip r:embed="rId2">
+            <a:extLst>
+              <a:ext uri="{28A0092B-C50C-407E-A947-70E740481C1C}">
+                <a14:useLocalDpi xmlns:a14="http://schemas.microsoft.com/office/drawing/2010/main" val="0"/>
+              </a:ext>
+            </a:extLst>
+          </a:blip>
+          <a:srcRect/>
+          <a:stretch>
+            <a:fillRect/>
+          </a:stretch>
+        </p:blipFill>
+        <p:spPr bwMode="auto">
+          <a:xfrm>
+            <a:off x="812230" y="2718255"/>
+            <a:ext cx="1397338" cy="1289850"/>
+          </a:xfrm>
+          <a:prstGeom prst="rect">
+            <a:avLst/>
+          </a:prstGeom>
+          <a:noFill/>
+          <a:extLst>
+            <a:ext uri="{909E8E84-426E-40DD-AFC4-6F175D3DCCD1}">
+              <a14:hiddenFill xmlns:a14="http://schemas.microsoft.com/office/drawing/2010/main">
+                <a:solidFill>
+                  <a:srgbClr val="FFFFFF"/>
+                </a:solidFill>
+              </a14:hiddenFill>
+            </a:ext>
+          </a:extLst>
+        </p:spPr>
+      </p:pic>
+      <p:sp>
+        <p:nvSpPr>
+          <p:cNvPr id="10" name="Rectangle 3">
+            <a:extLst>
+              <a:ext uri="{FF2B5EF4-FFF2-40B4-BE49-F238E27FC236}">
+                <a16:creationId xmlns:a16="http://schemas.microsoft.com/office/drawing/2014/main" id="{407D7363-CE26-E772-5F3C-8A634EF3B50A}"/>
+              </a:ext>
+            </a:extLst>
+          </p:cNvPr>
+          <p:cNvSpPr>
+            <a:spLocks noChangeArrowheads="1"/>
+          </p:cNvSpPr>
+          <p:nvPr/>
+        </p:nvSpPr>
+        <p:spPr bwMode="auto">
+          <a:xfrm rot="10800000" flipV="1">
+            <a:off x="1016317" y="4053935"/>
+            <a:ext cx="2100837" cy="246221"/>
+          </a:xfrm>
+          <a:prstGeom prst="rect">
+            <a:avLst/>
+          </a:prstGeom>
+          <a:noFill/>
+          <a:ln>
+            <a:noFill/>
+          </a:ln>
+          <a:effectLst/>
+          <a:extLst>
+            <a:ext uri="{909E8E84-426E-40DD-AFC4-6F175D3DCCD1}">
+              <a14:hiddenFill xmlns:a14="http://schemas.microsoft.com/office/drawing/2010/main">
+                <a:solidFill>
+                  <a:schemeClr val="accent1"/>
+                </a:solidFill>
+              </a14:hiddenFill>
+            </a:ext>
+            <a:ext uri="{91240B29-F687-4F45-9708-019B960494DF}">
+              <a14:hiddenLine xmlns:a14="http://schemas.microsoft.com/office/drawing/2010/main" w="9525">
+                <a:solidFill>
+                  <a:schemeClr val="tx1"/>
+                </a:solidFill>
+                <a:miter lim="800000"/>
+                <a:headEnd/>
+                <a:tailEnd/>
+              </a14:hiddenLine>
+            </a:ext>
+            <a:ext uri="{AF507438-7753-43E0-B8FC-AC1667EBCBE1}">
+              <a14:hiddenEffects xmlns:a14="http://schemas.microsoft.com/office/drawing/2010/main">
+                <a:effectLst>
+                  <a:outerShdw dist="35921" dir="2700000" algn="ctr" rotWithShape="0">
+                    <a:schemeClr val="bg2"/>
+                  </a:outerShdw>
+                </a:effectLst>
+              </a14:hiddenEffects>
+            </a:ext>
+          </a:extLst>
+        </p:spPr>
+        <p:txBody>
+          <a:bodyPr vert="horz" wrap="square" lIns="91440" tIns="45720" rIns="91440" bIns="45720" numCol="1" anchor="ctr" anchorCtr="0" compatLnSpc="1">
+            <a:prstTxWarp prst="textNoShape">
+              <a:avLst/>
+            </a:prstTxWarp>
+            <a:spAutoFit/>
+          </a:bodyPr>
+          <a:lstStyle/>
+          <a:p>
+            <a:pPr marL="0" marR="0" lvl="0" indent="0" algn="l" defTabSz="914400" rtl="0" eaLnBrk="0" fontAlgn="base" latinLnBrk="0" hangingPunct="0">
+              <a:lnSpc>
+                <a:spcPct val="100000"/>
+              </a:lnSpc>
+              <a:spcBef>
+                <a:spcPct val="0"/>
+              </a:spcBef>
+              <a:spcAft>
+                <a:spcPct val="0"/>
+              </a:spcAft>
+              <a:buClrTx/>
+              <a:buSzTx/>
+              <a:buFontTx/>
+              <a:buNone/>
+              <a:tabLst/>
+            </a:pPr>
+            <a:r>
+              <a:rPr kumimoji="0" lang="ja-JP" altLang="ja-JP" sz="1000" b="1" i="0" u="none" strike="noStrike" cap="none" normalizeH="0" baseline="0" dirty="0">
+                <a:ln>
+                  <a:noFill/>
+                </a:ln>
+                <a:solidFill>
+                  <a:schemeClr val="tx1"/>
+                </a:solidFill>
+                <a:effectLst/>
+                <a:latin typeface="Times New Roman" panose="02020603050405020304" pitchFamily="18" charset="0"/>
+                <a:ea typeface="游明朝" panose="02020400000000000000" pitchFamily="18" charset="-128"/>
+                <a:cs typeface="Times New Roman" panose="02020603050405020304" pitchFamily="18" charset="0"/>
+              </a:rPr>
+              <a:t>図 </a:t>
+            </a:r>
+            <a:r>
+              <a:rPr kumimoji="0" lang="en-US" altLang="ja-JP" sz="1000" b="1" i="0" u="none" strike="noStrike" cap="none" normalizeH="0" baseline="0" dirty="0">
+                <a:ln>
+                  <a:noFill/>
+                </a:ln>
+                <a:solidFill>
+                  <a:schemeClr val="tx1"/>
+                </a:solidFill>
+                <a:effectLst/>
+                <a:latin typeface="Times New Roman" panose="02020603050405020304" pitchFamily="18" charset="0"/>
+                <a:ea typeface="游明朝" panose="02020400000000000000" pitchFamily="18" charset="-128"/>
+                <a:cs typeface="Times New Roman" panose="02020603050405020304" pitchFamily="18" charset="0"/>
+              </a:rPr>
+              <a:t>1</a:t>
+            </a:r>
+            <a:r>
+              <a:rPr kumimoji="0" lang="ja-JP" altLang="en-US" sz="1000" b="1" i="0" u="none" strike="noStrike" cap="none" normalizeH="0" baseline="0" dirty="0">
+                <a:ln>
+                  <a:noFill/>
+                </a:ln>
+                <a:solidFill>
+                  <a:schemeClr val="tx1"/>
+                </a:solidFill>
+                <a:effectLst/>
+                <a:latin typeface="Times New Roman" panose="02020603050405020304" pitchFamily="18" charset="0"/>
+                <a:ea typeface="游明朝" panose="02020400000000000000" pitchFamily="18" charset="-128"/>
+                <a:cs typeface="Times New Roman" panose="02020603050405020304" pitchFamily="18" charset="0"/>
+              </a:rPr>
+              <a:t>ドーナツ</a:t>
+            </a:r>
+            <a:endParaRPr kumimoji="0" lang="ja-JP" altLang="en-US" sz="1800" b="0" i="0" u="none" strike="noStrike" cap="none" normalizeH="0" baseline="0" dirty="0">
+              <a:ln>
+                <a:noFill/>
+              </a:ln>
+              <a:solidFill>
+                <a:schemeClr val="tx1"/>
+              </a:solidFill>
+              <a:effectLst/>
+              <a:latin typeface="Arial" panose="020B0604020202020204" pitchFamily="34" charset="0"/>
+            </a:endParaRPr>
+          </a:p>
+        </p:txBody>
+      </p:sp>
+      <p:sp>
+        <p:nvSpPr>
+          <p:cNvPr id="11" name="Rectangle 5">
+            <a:extLst>
+              <a:ext uri="{FF2B5EF4-FFF2-40B4-BE49-F238E27FC236}">
+                <a16:creationId xmlns:a16="http://schemas.microsoft.com/office/drawing/2014/main" id="{9F29AA87-1662-9691-6E6C-CF249436E10A}"/>
+              </a:ext>
+            </a:extLst>
+          </p:cNvPr>
+          <p:cNvSpPr>
+            <a:spLocks noChangeArrowheads="1"/>
+          </p:cNvSpPr>
+          <p:nvPr/>
+        </p:nvSpPr>
+        <p:spPr bwMode="auto">
+          <a:xfrm>
+            <a:off x="4235982" y="2764976"/>
+            <a:ext cx="6440091" cy="769441"/>
+          </a:xfrm>
+          <a:prstGeom prst="rect">
+            <a:avLst/>
+          </a:prstGeom>
+          <a:noFill/>
+          <a:ln>
+            <a:noFill/>
+          </a:ln>
+          <a:effectLst/>
+          <a:extLst>
+            <a:ext uri="{909E8E84-426E-40DD-AFC4-6F175D3DCCD1}">
+              <a14:hiddenFill xmlns:a14="http://schemas.microsoft.com/office/drawing/2010/main">
+                <a:solidFill>
+                  <a:schemeClr val="accent1"/>
+                </a:solidFill>
+              </a14:hiddenFill>
+            </a:ext>
+            <a:ext uri="{91240B29-F687-4F45-9708-019B960494DF}">
+              <a14:hiddenLine xmlns:a14="http://schemas.microsoft.com/office/drawing/2010/main" w="9525">
+                <a:solidFill>
+                  <a:schemeClr val="tx1"/>
+                </a:solidFill>
+                <a:miter lim="800000"/>
+                <a:headEnd/>
+                <a:tailEnd/>
+              </a14:hiddenLine>
+            </a:ext>
+            <a:ext uri="{AF507438-7753-43E0-B8FC-AC1667EBCBE1}">
+              <a14:hiddenEffects xmlns:a14="http://schemas.microsoft.com/office/drawing/2010/main">
+                <a:effectLst>
+                  <a:outerShdw dist="35921" dir="2700000" algn="ctr" rotWithShape="0">
+                    <a:schemeClr val="bg2"/>
+                  </a:outerShdw>
+                </a:effectLst>
+              </a14:hiddenEffects>
+            </a:ext>
+          </a:extLst>
+        </p:spPr>
+        <p:txBody>
+          <a:bodyPr vert="horz" wrap="square" lIns="91440" tIns="45720" rIns="91440" bIns="45720" numCol="1" anchor="ctr" anchorCtr="0" compatLnSpc="1">
+            <a:prstTxWarp prst="textNoShape">
+              <a:avLst/>
+            </a:prstTxWarp>
+            <a:spAutoFit/>
+          </a:bodyPr>
+          <a:lstStyle/>
+          <a:p>
+            <a:pPr marL="0" marR="0" lvl="0" indent="0" algn="l" defTabSz="914400" rtl="0" eaLnBrk="0" fontAlgn="base" latinLnBrk="0" hangingPunct="0">
+              <a:lnSpc>
+                <a:spcPct val="100000"/>
+              </a:lnSpc>
+              <a:spcBef>
+                <a:spcPct val="0"/>
+              </a:spcBef>
+              <a:spcAft>
+                <a:spcPct val="0"/>
+              </a:spcAft>
+              <a:buClrTx/>
+              <a:buSzTx/>
+              <a:buFontTx/>
+              <a:buNone/>
+              <a:tabLst/>
+            </a:pPr>
+            <a:r>
+              <a:rPr kumimoji="0" lang="ja-JP" altLang="ja-JP" sz="1600" b="0" i="0" u="none" strike="noStrike" cap="none" normalizeH="0" baseline="0" dirty="0">
+                <a:ln>
+                  <a:noFill/>
+                </a:ln>
+                <a:solidFill>
+                  <a:srgbClr val="2E74B5"/>
+                </a:solidFill>
+                <a:effectLst/>
+                <a:latin typeface="游明朝" panose="02020400000000000000" pitchFamily="18" charset="-128"/>
+                <a:ea typeface="游明朝" panose="02020400000000000000" pitchFamily="18" charset="-128"/>
+                <a:cs typeface="Times New Roman" panose="02020603050405020304" pitchFamily="18" charset="0"/>
+              </a:rPr>
+              <a:t>調査結果</a:t>
+            </a:r>
+            <a:endParaRPr kumimoji="0" lang="ja-JP" altLang="ja-JP" sz="1600" b="0" i="0" u="none" strike="noStrike" cap="none" normalizeH="0" baseline="0" dirty="0">
+              <a:ln>
+                <a:noFill/>
+              </a:ln>
+              <a:solidFill>
+                <a:srgbClr val="2E74B5"/>
+              </a:solidFill>
+              <a:effectLst/>
+              <a:latin typeface="Times New Roman" panose="02020603050405020304" pitchFamily="18" charset="0"/>
+              <a:cs typeface="Times New Roman" panose="02020603050405020304" pitchFamily="18" charset="0"/>
+            </a:endParaRPr>
+          </a:p>
+          <a:p>
+            <a:pPr marL="0" marR="0" lvl="0" indent="0" algn="l" defTabSz="914400" rtl="0" eaLnBrk="0" fontAlgn="base" latinLnBrk="0" hangingPunct="0">
+              <a:lnSpc>
+                <a:spcPct val="100000"/>
+              </a:lnSpc>
+              <a:spcBef>
+                <a:spcPct val="0"/>
+              </a:spcBef>
+              <a:spcAft>
+                <a:spcPct val="0"/>
+              </a:spcAft>
+              <a:buClrTx/>
+              <a:buSzTx/>
+              <a:buFontTx/>
+              <a:buNone/>
+              <a:tabLst/>
+            </a:pPr>
+            <a:r>
+              <a:rPr kumimoji="0" lang="ja-JP" altLang="ja-JP" sz="1000" b="1" i="0" u="none" strike="noStrike" cap="none" normalizeH="0" baseline="0" dirty="0">
+                <a:ln>
+                  <a:noFill/>
+                </a:ln>
+                <a:solidFill>
+                  <a:schemeClr val="tx1"/>
+                </a:solidFill>
+                <a:effectLst/>
+                <a:latin typeface="Times New Roman" panose="02020603050405020304" pitchFamily="18" charset="0"/>
+                <a:ea typeface="游明朝" panose="02020400000000000000" pitchFamily="18" charset="-128"/>
+                <a:cs typeface="Times New Roman" panose="02020603050405020304" pitchFamily="18" charset="0"/>
+              </a:rPr>
+              <a:t>表 </a:t>
+            </a:r>
+            <a:r>
+              <a:rPr kumimoji="0" lang="en-US" altLang="ja-JP" sz="1000" b="1" i="0" u="none" strike="noStrike" cap="none" normalizeH="0" baseline="0" dirty="0">
+                <a:ln>
+                  <a:noFill/>
+                </a:ln>
+                <a:solidFill>
+                  <a:schemeClr val="tx1"/>
+                </a:solidFill>
+                <a:effectLst/>
+                <a:latin typeface="Times New Roman" panose="02020603050405020304" pitchFamily="18" charset="0"/>
+                <a:ea typeface="游明朝" panose="02020400000000000000" pitchFamily="18" charset="-128"/>
+                <a:cs typeface="Times New Roman" panose="02020603050405020304" pitchFamily="18" charset="0"/>
+              </a:rPr>
+              <a:t>2</a:t>
+            </a:r>
+            <a:r>
+              <a:rPr kumimoji="0" lang="ja-JP" altLang="en-US" sz="1000" b="1" i="0" u="none" strike="noStrike" cap="none" normalizeH="0" baseline="0" dirty="0">
+                <a:ln>
+                  <a:noFill/>
+                </a:ln>
+                <a:solidFill>
+                  <a:schemeClr val="tx1"/>
+                </a:solidFill>
+                <a:effectLst/>
+                <a:latin typeface="Times New Roman" panose="02020603050405020304" pitchFamily="18" charset="0"/>
+                <a:ea typeface="游明朝" panose="02020400000000000000" pitchFamily="18" charset="-128"/>
+                <a:cs typeface="Times New Roman" panose="02020603050405020304" pitchFamily="18" charset="0"/>
+              </a:rPr>
+              <a:t>　生命保険</a:t>
+            </a:r>
+            <a:endParaRPr kumimoji="0" lang="ja-JP" altLang="en-US" sz="600" b="0" i="0" u="none" strike="noStrike" cap="none" normalizeH="0" baseline="0" dirty="0">
+              <a:ln>
+                <a:noFill/>
+              </a:ln>
+              <a:solidFill>
+                <a:schemeClr val="tx1"/>
+              </a:solidFill>
+              <a:effectLst/>
+            </a:endParaRPr>
+          </a:p>
+          <a:p>
+            <a:pPr marL="0" marR="0" lvl="0" indent="0" algn="l" defTabSz="914400" rtl="0" eaLnBrk="0" fontAlgn="base" latinLnBrk="0" hangingPunct="0">
+              <a:lnSpc>
+                <a:spcPct val="100000"/>
+              </a:lnSpc>
+              <a:spcBef>
+                <a:spcPct val="0"/>
+              </a:spcBef>
+              <a:spcAft>
+                <a:spcPct val="0"/>
+              </a:spcAft>
+              <a:buClrTx/>
+              <a:buSzTx/>
+              <a:buFontTx/>
+              <a:buNone/>
+              <a:tabLst/>
+            </a:pPr>
+            <a:endParaRPr kumimoji="0" lang="ja-JP" altLang="en-US" sz="1800" b="0" i="0" u="none" strike="noStrike" cap="none" normalizeH="0" baseline="0" dirty="0">
+              <a:ln>
+                <a:noFill/>
+              </a:ln>
+              <a:solidFill>
+                <a:schemeClr val="tx1"/>
+              </a:solidFill>
+              <a:effectLst/>
+              <a:latin typeface="Arial" panose="020B0604020202020204" pitchFamily="34" charset="0"/>
+            </a:endParaRPr>
+          </a:p>
+        </p:txBody>
+      </p:sp>
+      <p:pic>
+        <p:nvPicPr>
+          <p:cNvPr id="2052" name="図 1">
+            <a:extLst>
+              <a:ext uri="{FF2B5EF4-FFF2-40B4-BE49-F238E27FC236}">
+                <a16:creationId xmlns:a16="http://schemas.microsoft.com/office/drawing/2014/main" id="{572C91DD-50CA-E977-49FF-254C2E38C217}"/>
+              </a:ext>
+            </a:extLst>
+          </p:cNvPr>
+          <p:cNvPicPr>
+            <a:picLocks noChangeAspect="1" noChangeArrowheads="1"/>
+          </p:cNvPicPr>
+          <p:nvPr/>
+        </p:nvPicPr>
+        <p:blipFill>
+          <a:blip r:embed="rId3">
+            <a:extLst>
+              <a:ext uri="{28A0092B-C50C-407E-A947-70E740481C1C}">
+                <a14:useLocalDpi xmlns:a14="http://schemas.microsoft.com/office/drawing/2010/main" val="0"/>
+              </a:ext>
+            </a:extLst>
+          </a:blip>
+          <a:srcRect/>
+          <a:stretch>
+            <a:fillRect/>
+          </a:stretch>
+        </p:blipFill>
+        <p:spPr bwMode="auto">
+          <a:xfrm>
+            <a:off x="4360053" y="3314824"/>
+            <a:ext cx="4038474" cy="1489271"/>
+          </a:xfrm>
+          <a:prstGeom prst="rect">
+            <a:avLst/>
+          </a:prstGeom>
+          <a:noFill/>
+          <a:extLst>
+            <a:ext uri="{909E8E84-426E-40DD-AFC4-6F175D3DCCD1}">
+              <a14:hiddenFill xmlns:a14="http://schemas.microsoft.com/office/drawing/2010/main">
+                <a:solidFill>
+                  <a:srgbClr val="FFFFFF"/>
+                </a:solidFill>
+              </a14:hiddenFill>
+            </a:ext>
+          </a:extLst>
+        </p:spPr>
+      </p:pic>
+      <p:sp>
+        <p:nvSpPr>
+          <p:cNvPr id="12" name="Rectangle 6">
+            <a:extLst>
+              <a:ext uri="{FF2B5EF4-FFF2-40B4-BE49-F238E27FC236}">
+                <a16:creationId xmlns:a16="http://schemas.microsoft.com/office/drawing/2014/main" id="{CBA721E1-FB1D-18D6-CA4A-C4B40B3CF350}"/>
+              </a:ext>
+            </a:extLst>
+          </p:cNvPr>
+          <p:cNvSpPr>
+            <a:spLocks noChangeArrowheads="1"/>
+          </p:cNvSpPr>
+          <p:nvPr/>
+        </p:nvSpPr>
+        <p:spPr bwMode="auto">
+          <a:xfrm flipV="1">
+            <a:off x="5368385" y="4804095"/>
+            <a:ext cx="6440091" cy="45719"/>
+          </a:xfrm>
+          <a:prstGeom prst="rect">
+            <a:avLst/>
+          </a:prstGeom>
+          <a:noFill/>
+          <a:ln>
+            <a:noFill/>
+          </a:ln>
+          <a:effectLst/>
+          <a:extLst>
+            <a:ext uri="{909E8E84-426E-40DD-AFC4-6F175D3DCCD1}">
+              <a14:hiddenFill xmlns:a14="http://schemas.microsoft.com/office/drawing/2010/main">
+                <a:solidFill>
+                  <a:schemeClr val="accent1"/>
+                </a:solidFill>
+              </a14:hiddenFill>
+            </a:ext>
+            <a:ext uri="{91240B29-F687-4F45-9708-019B960494DF}">
+              <a14:hiddenLine xmlns:a14="http://schemas.microsoft.com/office/drawing/2010/main" w="9525">
+                <a:solidFill>
+                  <a:schemeClr val="tx1"/>
+                </a:solidFill>
+                <a:miter lim="800000"/>
+                <a:headEnd/>
+                <a:tailEnd/>
+              </a14:hiddenLine>
+            </a:ext>
+            <a:ext uri="{AF507438-7753-43E0-B8FC-AC1667EBCBE1}">
+              <a14:hiddenEffects xmlns:a14="http://schemas.microsoft.com/office/drawing/2010/main">
+                <a:effectLst>
+                  <a:outerShdw dist="35921" dir="2700000" algn="ctr" rotWithShape="0">
+                    <a:schemeClr val="bg2"/>
+                  </a:outerShdw>
+                </a:effectLst>
+              </a14:hiddenEffects>
+            </a:ext>
+          </a:extLst>
+        </p:spPr>
+        <p:txBody>
+          <a:bodyPr vert="horz" wrap="square" lIns="91440" tIns="45720" rIns="91440" bIns="45720" numCol="1" anchor="ctr" anchorCtr="0" compatLnSpc="1">
+            <a:prstTxWarp prst="textNoShape">
+              <a:avLst/>
+            </a:prstTxWarp>
+            <a:spAutoFit/>
+          </a:bodyPr>
+          <a:lstStyle/>
+          <a:p>
+            <a:endParaRPr lang="ja-JP" altLang="en-US"/>
+          </a:p>
+        </p:txBody>
+      </p:sp>
+    </p:spTree>
+    <p:extLst>
+      <p:ext uri="{BB962C8B-B14F-4D97-AF65-F5344CB8AC3E}">
+        <p14:creationId xmlns:p14="http://schemas.microsoft.com/office/powerpoint/2010/main" val="2532807656"/>
+      </p:ext>
+    </p:extLst>
   </p:cSld>
   <p:clrMapOvr>
     <a:masterClrMapping/>
@@ -2359,4 +4401,299 @@
     </a:ext>
   </a:extLst>
 </a:theme>
+</file>
+
+<file path=ppt/theme/theme2.xml><?xml version="1.0" encoding="utf-8"?>
+<a:theme xmlns:a="http://schemas.openxmlformats.org/drawingml/2006/main" name="Office テーマ">
+  <a:themeElements>
+    <a:clrScheme name="Office">
+      <a:dk1>
+        <a:sysClr val="windowText" lastClr="000000"/>
+      </a:dk1>
+      <a:lt1>
+        <a:sysClr val="window" lastClr="FFFFFF"/>
+      </a:lt1>
+      <a:dk2>
+        <a:srgbClr val="44546A"/>
+      </a:dk2>
+      <a:lt2>
+        <a:srgbClr val="E7E6E6"/>
+      </a:lt2>
+      <a:accent1>
+        <a:srgbClr val="4472C4"/>
+      </a:accent1>
+      <a:accent2>
+        <a:srgbClr val="ED7D31"/>
+      </a:accent2>
+      <a:accent3>
+        <a:srgbClr val="A5A5A5"/>
+      </a:accent3>
+      <a:accent4>
+        <a:srgbClr val="FFC000"/>
+      </a:accent4>
+      <a:accent5>
+        <a:srgbClr val="5B9BD5"/>
+      </a:accent5>
+      <a:accent6>
+        <a:srgbClr val="70AD47"/>
+      </a:accent6>
+      <a:hlink>
+        <a:srgbClr val="0563C1"/>
+      </a:hlink>
+      <a:folHlink>
+        <a:srgbClr val="954F72"/>
+      </a:folHlink>
+    </a:clrScheme>
+    <a:fontScheme name="Office">
+      <a:majorFont>
+        <a:latin typeface="游ゴシック Light" panose="020F0302020204030204"/>
+        <a:ea typeface=""/>
+        <a:cs typeface=""/>
+        <a:font script="Jpan" typeface="游ゴシック Light"/>
+        <a:font script="Hang" typeface="맑은 고딕"/>
+        <a:font script="Hans" typeface="等线 Light"/>
+        <a:font script="Hant" typeface="新細明體"/>
+        <a:font script="Arab" typeface="Times New Roman"/>
+        <a:font script="Hebr" typeface="Times New Roman"/>
+        <a:font script="Thai" typeface="Angsana New"/>
+        <a:font script="Ethi" typeface="Nyala"/>
+        <a:font script="Beng" typeface="Vrinda"/>
+        <a:font script="Gujr" typeface="Shruti"/>
+        <a:font script="Khmr" typeface="MoolBoran"/>
+        <a:font script="Knda" typeface="Tunga"/>
+        <a:font script="Guru" typeface="Raavi"/>
+        <a:font script="Cans" typeface="Euphemia"/>
+        <a:font script="Cher" typeface="Plantagenet Cherokee"/>
+        <a:font script="Yiii" typeface="Microsoft Yi Baiti"/>
+        <a:font script="Tibt" typeface="Microsoft Himalaya"/>
+        <a:font script="Thaa" typeface="MV Boli"/>
+        <a:font script="Deva" typeface="Mangal"/>
+        <a:font script="Telu" typeface="Gautami"/>
+        <a:font script="Taml" typeface="Latha"/>
+        <a:font script="Syrc" typeface="Estrangelo Edessa"/>
+        <a:font script="Orya" typeface="Kalinga"/>
+        <a:font script="Mlym" typeface="Kartika"/>
+        <a:font script="Laoo" typeface="DokChampa"/>
+        <a:font script="Sinh" typeface="Iskoola Pota"/>
+        <a:font script="Mong" typeface="Mongolian Baiti"/>
+        <a:font script="Viet" typeface="Times New Roman"/>
+        <a:font script="Uigh" typeface="Microsoft Uighur"/>
+        <a:font script="Geor" typeface="Sylfaen"/>
+        <a:font script="Armn" typeface="Arial"/>
+        <a:font script="Bugi" typeface="Leelawadee UI"/>
+        <a:font script="Bopo" typeface="Microsoft JhengHei"/>
+        <a:font script="Java" typeface="Javanese Text"/>
+        <a:font script="Lisu" typeface="Segoe UI"/>
+        <a:font script="Mymr" typeface="Myanmar Text"/>
+        <a:font script="Nkoo" typeface="Ebrima"/>
+        <a:font script="Olck" typeface="Nirmala UI"/>
+        <a:font script="Osma" typeface="Ebrima"/>
+        <a:font script="Phag" typeface="Phagspa"/>
+        <a:font script="Syrn" typeface="Estrangelo Edessa"/>
+        <a:font script="Syrj" typeface="Estrangelo Edessa"/>
+        <a:font script="Syre" typeface="Estrangelo Edessa"/>
+        <a:font script="Sora" typeface="Nirmala UI"/>
+        <a:font script="Tale" typeface="Microsoft Tai Le"/>
+        <a:font script="Talu" typeface="Microsoft New Tai Lue"/>
+        <a:font script="Tfng" typeface="Ebrima"/>
+      </a:majorFont>
+      <a:minorFont>
+        <a:latin typeface="游ゴシック" panose="020F0502020204030204"/>
+        <a:ea typeface=""/>
+        <a:cs typeface=""/>
+        <a:font script="Jpan" typeface="游ゴシック"/>
+        <a:font script="Hang" typeface="맑은 고딕"/>
+        <a:font script="Hans" typeface="等线"/>
+        <a:font script="Hant" typeface="新細明體"/>
+        <a:font script="Arab" typeface="Arial"/>
+        <a:font script="Hebr" typeface="Arial"/>
+        <a:font script="Thai" typeface="Cordia New"/>
+        <a:font script="Ethi" typeface="Nyala"/>
+        <a:font script="Beng" typeface="Vrinda"/>
+        <a:font script="Gujr" typeface="Shruti"/>
+        <a:font script="Khmr" typeface="DaunPenh"/>
+        <a:font script="Knda" typeface="Tunga"/>
+        <a:font script="Guru" typeface="Raavi"/>
+        <a:font script="Cans" typeface="Euphemia"/>
+        <a:font script="Cher" typeface="Plantagenet Cherokee"/>
+        <a:font script="Yiii" typeface="Microsoft Yi Baiti"/>
+        <a:font script="Tibt" typeface="Microsoft Himalaya"/>
+        <a:font script="Thaa" typeface="MV Boli"/>
+        <a:font script="Deva" typeface="Mangal"/>
+        <a:font script="Telu" typeface="Gautami"/>
+        <a:font script="Taml" typeface="Latha"/>
+        <a:font script="Syrc" typeface="Estrangelo Edessa"/>
+        <a:font script="Orya" typeface="Kalinga"/>
+        <a:font script="Mlym" typeface="Kartika"/>
+        <a:font script="Laoo" typeface="DokChampa"/>
+        <a:font script="Sinh" typeface="Iskoola Pota"/>
+        <a:font script="Mong" typeface="Mongolian Baiti"/>
+        <a:font script="Viet" typeface="Arial"/>
+        <a:font script="Uigh" typeface="Microsoft Uighur"/>
+        <a:font script="Geor" typeface="Sylfaen"/>
+        <a:font script="Armn" typeface="Arial"/>
+        <a:font script="Bugi" typeface="Leelawadee UI"/>
+        <a:font script="Bopo" typeface="Microsoft JhengHei"/>
+        <a:font script="Java" typeface="Javanese Text"/>
+        <a:font script="Lisu" typeface="Segoe UI"/>
+        <a:font script="Mymr" typeface="Myanmar Text"/>
+        <a:font script="Nkoo" typeface="Ebrima"/>
+        <a:font script="Olck" typeface="Nirmala UI"/>
+        <a:font script="Osma" typeface="Ebrima"/>
+        <a:font script="Phag" typeface="Phagspa"/>
+        <a:font script="Syrn" typeface="Estrangelo Edessa"/>
+        <a:font script="Syrj" typeface="Estrangelo Edessa"/>
+        <a:font script="Syre" typeface="Estrangelo Edessa"/>
+        <a:font script="Sora" typeface="Nirmala UI"/>
+        <a:font script="Tale" typeface="Microsoft Tai Le"/>
+        <a:font script="Talu" typeface="Microsoft New Tai Lue"/>
+        <a:font script="Tfng" typeface="Ebrima"/>
+      </a:minorFont>
+    </a:fontScheme>
+    <a:fmtScheme name="Office">
+      <a:fillStyleLst>
+        <a:solidFill>
+          <a:schemeClr val="phClr"/>
+        </a:solidFill>
+        <a:gradFill rotWithShape="1">
+          <a:gsLst>
+            <a:gs pos="0">
+              <a:schemeClr val="phClr">
+                <a:lumMod val="110000"/>
+                <a:satMod val="105000"/>
+                <a:tint val="67000"/>
+              </a:schemeClr>
+            </a:gs>
+            <a:gs pos="50000">
+              <a:schemeClr val="phClr">
+                <a:lumMod val="105000"/>
+                <a:satMod val="103000"/>
+                <a:tint val="73000"/>
+              </a:schemeClr>
+            </a:gs>
+            <a:gs pos="100000">
+              <a:schemeClr val="phClr">
+                <a:lumMod val="105000"/>
+                <a:satMod val="109000"/>
+                <a:tint val="81000"/>
+              </a:schemeClr>
+            </a:gs>
+          </a:gsLst>
+          <a:lin ang="5400000" scaled="0"/>
+        </a:gradFill>
+        <a:gradFill rotWithShape="1">
+          <a:gsLst>
+            <a:gs pos="0">
+              <a:schemeClr val="phClr">
+                <a:satMod val="103000"/>
+                <a:lumMod val="102000"/>
+                <a:tint val="94000"/>
+              </a:schemeClr>
+            </a:gs>
+            <a:gs pos="50000">
+              <a:schemeClr val="phClr">
+                <a:satMod val="110000"/>
+                <a:lumMod val="100000"/>
+                <a:shade val="100000"/>
+              </a:schemeClr>
+            </a:gs>
+            <a:gs pos="100000">
+              <a:schemeClr val="phClr">
+                <a:lumMod val="99000"/>
+                <a:satMod val="120000"/>
+                <a:shade val="78000"/>
+              </a:schemeClr>
+            </a:gs>
+          </a:gsLst>
+          <a:lin ang="5400000" scaled="0"/>
+        </a:gradFill>
+      </a:fillStyleLst>
+      <a:lnStyleLst>
+        <a:ln w="6350" cap="flat" cmpd="sng" algn="ctr">
+          <a:solidFill>
+            <a:schemeClr val="phClr"/>
+          </a:solidFill>
+          <a:prstDash val="solid"/>
+          <a:miter lim="800000"/>
+        </a:ln>
+        <a:ln w="12700" cap="flat" cmpd="sng" algn="ctr">
+          <a:solidFill>
+            <a:schemeClr val="phClr"/>
+          </a:solidFill>
+          <a:prstDash val="solid"/>
+          <a:miter lim="800000"/>
+        </a:ln>
+        <a:ln w="19050" cap="flat" cmpd="sng" algn="ctr">
+          <a:solidFill>
+            <a:schemeClr val="phClr"/>
+          </a:solidFill>
+          <a:prstDash val="solid"/>
+          <a:miter lim="800000"/>
+        </a:ln>
+      </a:lnStyleLst>
+      <a:effectStyleLst>
+        <a:effectStyle>
+          <a:effectLst/>
+        </a:effectStyle>
+        <a:effectStyle>
+          <a:effectLst/>
+        </a:effectStyle>
+        <a:effectStyle>
+          <a:effectLst>
+            <a:outerShdw blurRad="57150" dist="19050" dir="5400000" algn="ctr" rotWithShape="0">
+              <a:srgbClr val="000000">
+                <a:alpha val="63000"/>
+              </a:srgbClr>
+            </a:outerShdw>
+          </a:effectLst>
+        </a:effectStyle>
+      </a:effectStyleLst>
+      <a:bgFillStyleLst>
+        <a:solidFill>
+          <a:schemeClr val="phClr"/>
+        </a:solidFill>
+        <a:solidFill>
+          <a:schemeClr val="phClr">
+            <a:tint val="95000"/>
+            <a:satMod val="170000"/>
+          </a:schemeClr>
+        </a:solidFill>
+        <a:gradFill rotWithShape="1">
+          <a:gsLst>
+            <a:gs pos="0">
+              <a:schemeClr val="phClr">
+                <a:tint val="93000"/>
+                <a:satMod val="150000"/>
+                <a:shade val="98000"/>
+                <a:lumMod val="102000"/>
+              </a:schemeClr>
+            </a:gs>
+            <a:gs pos="50000">
+              <a:schemeClr val="phClr">
+                <a:tint val="98000"/>
+                <a:satMod val="130000"/>
+                <a:shade val="90000"/>
+                <a:lumMod val="103000"/>
+              </a:schemeClr>
+            </a:gs>
+            <a:gs pos="100000">
+              <a:schemeClr val="phClr">
+                <a:shade val="63000"/>
+                <a:satMod val="120000"/>
+              </a:schemeClr>
+            </a:gs>
+          </a:gsLst>
+          <a:lin ang="5400000" scaled="0"/>
+        </a:gradFill>
+      </a:bgFillStyleLst>
+    </a:fmtScheme>
+  </a:themeElements>
+  <a:objectDefaults/>
+  <a:extraClrSchemeLst/>
+  <a:extLst>
+    <a:ext uri="{05A4C25C-085E-4340-85A3-A5531E510DB2}">
+      <thm15:themeFamily xmlns:thm15="http://schemas.microsoft.com/office/thememl/2012/main" name="Office Theme" id="{62F939B6-93AF-4DB8-9C6B-D6C7DFDC589F}" vid="{4A3C46E8-61CC-4603-A589-7422A47A8E4A}"/>
+    </a:ext>
+  </a:extLst>
+</a:theme>
 </file>
</xml_diff>